<commit_message>
feat(downgrade): two-file report export + refset-aligned report UI
- report_doc: download ZIP is now report.md (apply guide) + evidence.md
  (proof appendix); drop the stale raw file tree that shipped one recorded
  output and omitted the reference set the verdict is based on. Fix refset
  field reads (system, cheaper-fit rate) and reference-set 'why it's safe'.
- report.html: cheaper re-runs judged against the reference set (no
  before/after vs a single recorded output); reusable framed iobox with
  shaded header + per-box expand; remove hard output truncation.
- recorded source: gate visibility on AUDIT_DEBUG.
- DOWNGRADE-DESIGN.md: authoritative reference-set design.
- deck: reference-set downgrade flow.

Validated via a constructed failure battery (worse-cheaper, inconsistent-
original, format-drift) — correct and stable across re-runs.

Co-Authored-By: Claude Opus 4.8 <noreply@anthropic.com>
</commit_message>
<xml_diff>
--- a/docs/token-auditor-deck.pptx
+++ b/docs/token-auditor-deck.pptx
@@ -4,20 +4,17 @@
   <p:sldMasterIdLst>
     <p:sldMasterId id="2147483648" r:id="rId1"/>
   </p:sldMasterIdLst>
-  <p:notesMasterIdLst>
-    <p:notesMasterId r:id="rId10"/>
-  </p:notesMasterIdLst>
   <p:sldIdLst>
-    <p:sldId id="256" r:id="rId2"/>
-    <p:sldId id="257" r:id="rId3"/>
-    <p:sldId id="258" r:id="rId4"/>
-    <p:sldId id="259" r:id="rId5"/>
-    <p:sldId id="260" r:id="rId6"/>
-    <p:sldId id="261" r:id="rId7"/>
-    <p:sldId id="262" r:id="rId8"/>
-    <p:sldId id="263" r:id="rId9"/>
+    <p:sldId id="256" r:id="rId7"/>
+    <p:sldId id="257" r:id="rId8"/>
+    <p:sldId id="258" r:id="rId9"/>
+    <p:sldId id="259" r:id="rId10"/>
+    <p:sldId id="260" r:id="rId12"/>
+    <p:sldId id="261" r:id="rId13"/>
+    <p:sldId id="262" r:id="rId14"/>
+    <p:sldId id="263" r:id="rId15"/>
   </p:sldIdLst>
-  <p:sldSz cx="12192000" cy="6858000"/>
+  <p:sldSz cx="12191695" cy="6858000" type="screen4x3"/>
   <p:notesSz cx="6858000" cy="9144000"/>
   <p:defaultTextStyle>
     <a:defPPr>
@@ -114,27 +111,11 @@
       </a:defRPr>
     </a:lvl9pPr>
   </p:defaultTextStyle>
-  <p:extLst>
-    <p:ext uri="{EFAFB233-063F-42B5-8137-9DF3F51BA10A}">
-      <p15:sldGuideLst xmlns:p15="http://schemas.microsoft.com/office/powerpoint/2012/main">
-        <p15:guide id="1" orient="horz" pos="2160">
-          <p15:clr>
-            <a:srgbClr val="A4A3A4"/>
-          </p15:clr>
-        </p15:guide>
-        <p15:guide id="2" pos="2880">
-          <p15:clr>
-            <a:srgbClr val="A4A3A4"/>
-          </p15:clr>
-        </p15:guide>
-      </p15:sldGuideLst>
-    </p:ext>
-  </p:extLst>
 </p:presentation>
 </file>
 
 <file path=ppt/notesMasters/notesMaster1.xml><?xml version="1.0" encoding="utf-8"?>
-<p:notesMaster xmlns:a="http://schemas.openxmlformats.org/drawingml/2006/main" xmlns:r="http://schemas.openxmlformats.org/officeDocument/2006/relationships" xmlns:p="http://schemas.openxmlformats.org/presentationml/2006/main">
+<p:notesMaster xmlns:a="http://schemas.openxmlformats.org/drawingml/2006/main" xmlns:p="http://schemas.openxmlformats.org/presentationml/2006/main" xmlns:r="http://schemas.openxmlformats.org/officeDocument/2006/relationships">
   <p:cSld>
     <p:bg>
       <p:bgRef idx="1001">
@@ -168,7 +149,7 @@
         <p:spPr>
           <a:xfrm>
             <a:off x="0" y="0"/>
-            <a:ext cx="2971800" cy="458788"/>
+            <a:ext cx="2971800" cy="457200"/>
           </a:xfrm>
           <a:prstGeom prst="rect">
             <a:avLst/>
@@ -182,7 +163,7 @@
             </a:lvl1pPr>
           </a:lstStyle>
           <a:p>
-            <a:endParaRPr lang="en-IN"/>
+            <a:endParaRPr lang="en-US"/>
           </a:p>
         </p:txBody>
       </p:sp>
@@ -199,7 +180,7 @@
         <p:spPr>
           <a:xfrm>
             <a:off x="3884613" y="0"/>
-            <a:ext cx="2971800" cy="458788"/>
+            <a:ext cx="2971800" cy="457200"/>
           </a:xfrm>
           <a:prstGeom prst="rect">
             <a:avLst/>
@@ -213,11 +194,11 @@
             </a:lvl1pPr>
           </a:lstStyle>
           <a:p>
-            <a:fld id="{2B034A6A-0F79-44C3-8127-7530B2C6BAFB}" type="datetimeFigureOut">
-              <a:rPr lang="en-IN" smtClean="0"/>
-              <a:t>11-08-2026</a:t>
+            <a:fld id="{0F89C1C7-3DCD-1040-A9CF-14679D8B5DDD}" type="datetimeFigureOut">
+              <a:rPr lang="en-US" smtClean="0"/>
+              <a:t>10/17/16</a:t>
             </a:fld>
-            <a:endParaRPr lang="en-IN"/>
+            <a:endParaRPr lang="en-US"/>
           </a:p>
         </p:txBody>
       </p:sp>
@@ -233,8 +214,8 @@
         </p:nvSpPr>
         <p:spPr>
           <a:xfrm>
-            <a:off x="685800" y="1143000"/>
-            <a:ext cx="5486400" cy="3086100"/>
+            <a:off x="1143000" y="685800"/>
+            <a:ext cx="4572000" cy="3429000"/>
           </a:xfrm>
           <a:prstGeom prst="rect">
             <a:avLst/>
@@ -250,7 +231,7 @@
           <a:bodyPr vert="horz" lIns="91440" tIns="45720" rIns="91440" bIns="45720" rtlCol="0" anchor="ctr"/>
           <a:lstStyle/>
           <a:p>
-            <a:endParaRPr lang="en-IN"/>
+            <a:endParaRPr lang="en-US"/>
           </a:p>
         </p:txBody>
       </p:sp>
@@ -266,8 +247,8 @@
         </p:nvSpPr>
         <p:spPr>
           <a:xfrm>
-            <a:off x="685800" y="4400550"/>
-            <a:ext cx="5486400" cy="3600450"/>
+            <a:off x="685800" y="4343400"/>
+            <a:ext cx="5486400" cy="4114800"/>
           </a:xfrm>
           <a:prstGeom prst="rect">
             <a:avLst/>
@@ -279,38 +260,38 @@
           <a:p>
             <a:pPr lvl="0"/>
             <a:r>
-              <a:rPr lang="en-US"/>
+              <a:rPr lang="en-US" smtClean="0"/>
               <a:t>Click to edit Master text styles</a:t>
             </a:r>
           </a:p>
           <a:p>
             <a:pPr lvl="1"/>
             <a:r>
-              <a:rPr lang="en-US"/>
+              <a:rPr lang="en-US" smtClean="0"/>
               <a:t>Second level</a:t>
             </a:r>
           </a:p>
           <a:p>
             <a:pPr lvl="2"/>
             <a:r>
-              <a:rPr lang="en-US"/>
+              <a:rPr lang="en-US" smtClean="0"/>
               <a:t>Third level</a:t>
             </a:r>
           </a:p>
           <a:p>
             <a:pPr lvl="3"/>
             <a:r>
-              <a:rPr lang="en-US"/>
+              <a:rPr lang="en-US" smtClean="0"/>
               <a:t>Fourth level</a:t>
             </a:r>
           </a:p>
           <a:p>
             <a:pPr lvl="4"/>
             <a:r>
-              <a:rPr lang="en-US"/>
+              <a:rPr lang="en-US" smtClean="0"/>
               <a:t>Fifth level</a:t>
             </a:r>
-            <a:endParaRPr lang="en-IN"/>
+            <a:endParaRPr lang="en-US"/>
           </a:p>
         </p:txBody>
       </p:sp>
@@ -327,7 +308,7 @@
         <p:spPr>
           <a:xfrm>
             <a:off x="0" y="8685213"/>
-            <a:ext cx="2971800" cy="458787"/>
+            <a:ext cx="2971800" cy="457200"/>
           </a:xfrm>
           <a:prstGeom prst="rect">
             <a:avLst/>
@@ -341,7 +322,7 @@
             </a:lvl1pPr>
           </a:lstStyle>
           <a:p>
-            <a:endParaRPr lang="en-IN"/>
+            <a:endParaRPr lang="en-US"/>
           </a:p>
         </p:txBody>
       </p:sp>
@@ -358,7 +339,7 @@
         <p:spPr>
           <a:xfrm>
             <a:off x="3884613" y="8685213"/>
-            <a:ext cx="2971800" cy="458787"/>
+            <a:ext cx="2971800" cy="457200"/>
           </a:xfrm>
           <a:prstGeom prst="rect">
             <a:avLst/>
@@ -372,24 +353,24 @@
             </a:lvl1pPr>
           </a:lstStyle>
           <a:p>
-            <a:fld id="{A1C52563-9AFB-46B2-9662-018DDF9C8461}" type="slidenum">
-              <a:rPr lang="en-IN" smtClean="0"/>
+            <a:fld id="{BB5E49A5-4136-284D-997B-48E1D791AD67}" type="slidenum">
+              <a:rPr lang="en-US" smtClean="0"/>
               <a:t>‹#›</a:t>
             </a:fld>
-            <a:endParaRPr lang="en-IN"/>
+            <a:endParaRPr lang="en-US"/>
           </a:p>
         </p:txBody>
       </p:sp>
     </p:spTree>
     <p:extLst>
       <p:ext uri="{BB962C8B-B14F-4D97-AF65-F5344CB8AC3E}">
-        <p14:creationId xmlns:p14="http://schemas.microsoft.com/office/powerpoint/2010/main" val="660932413"/>
+        <p14:creationId xmlns:p14="http://schemas.microsoft.com/office/powerpoint/2010/main" val="2623252185"/>
       </p:ext>
     </p:extLst>
   </p:cSld>
   <p:clrMap bg1="lt1" tx1="dk1" bg2="lt2" tx2="dk2" accent1="accent1" accent2="accent2" accent3="accent3" accent4="accent4" accent5="accent5" accent6="accent6" hlink="hlink" folHlink="folHlink"/>
   <p:notesStyle>
-    <a:lvl1pPr marL="0" algn="l" defTabSz="914400" rtl="0" eaLnBrk="1" latinLnBrk="0" hangingPunct="1">
+    <a:lvl1pPr marL="0" algn="l" defTabSz="457200" rtl="0" eaLnBrk="1" latinLnBrk="0" hangingPunct="1">
       <a:defRPr sz="1200" kern="1200">
         <a:solidFill>
           <a:schemeClr val="tx1"/>
@@ -399,7 +380,7 @@
         <a:cs typeface="+mn-cs"/>
       </a:defRPr>
     </a:lvl1pPr>
-    <a:lvl2pPr marL="457200" algn="l" defTabSz="914400" rtl="0" eaLnBrk="1" latinLnBrk="0" hangingPunct="1">
+    <a:lvl2pPr marL="457200" algn="l" defTabSz="457200" rtl="0" eaLnBrk="1" latinLnBrk="0" hangingPunct="1">
       <a:defRPr sz="1200" kern="1200">
         <a:solidFill>
           <a:schemeClr val="tx1"/>
@@ -409,7 +390,7 @@
         <a:cs typeface="+mn-cs"/>
       </a:defRPr>
     </a:lvl2pPr>
-    <a:lvl3pPr marL="914400" algn="l" defTabSz="914400" rtl="0" eaLnBrk="1" latinLnBrk="0" hangingPunct="1">
+    <a:lvl3pPr marL="914400" algn="l" defTabSz="457200" rtl="0" eaLnBrk="1" latinLnBrk="0" hangingPunct="1">
       <a:defRPr sz="1200" kern="1200">
         <a:solidFill>
           <a:schemeClr val="tx1"/>
@@ -419,7 +400,7 @@
         <a:cs typeface="+mn-cs"/>
       </a:defRPr>
     </a:lvl3pPr>
-    <a:lvl4pPr marL="1371600" algn="l" defTabSz="914400" rtl="0" eaLnBrk="1" latinLnBrk="0" hangingPunct="1">
+    <a:lvl4pPr marL="1371600" algn="l" defTabSz="457200" rtl="0" eaLnBrk="1" latinLnBrk="0" hangingPunct="1">
       <a:defRPr sz="1200" kern="1200">
         <a:solidFill>
           <a:schemeClr val="tx1"/>
@@ -429,7 +410,7 @@
         <a:cs typeface="+mn-cs"/>
       </a:defRPr>
     </a:lvl4pPr>
-    <a:lvl5pPr marL="1828800" algn="l" defTabSz="914400" rtl="0" eaLnBrk="1" latinLnBrk="0" hangingPunct="1">
+    <a:lvl5pPr marL="1828800" algn="l" defTabSz="457200" rtl="0" eaLnBrk="1" latinLnBrk="0" hangingPunct="1">
       <a:defRPr sz="1200" kern="1200">
         <a:solidFill>
           <a:schemeClr val="tx1"/>
@@ -439,7 +420,7 @@
         <a:cs typeface="+mn-cs"/>
       </a:defRPr>
     </a:lvl5pPr>
-    <a:lvl6pPr marL="2286000" algn="l" defTabSz="914400" rtl="0" eaLnBrk="1" latinLnBrk="0" hangingPunct="1">
+    <a:lvl6pPr marL="2286000" algn="l" defTabSz="457200" rtl="0" eaLnBrk="1" latinLnBrk="0" hangingPunct="1">
       <a:defRPr sz="1200" kern="1200">
         <a:solidFill>
           <a:schemeClr val="tx1"/>
@@ -449,7 +430,7 @@
         <a:cs typeface="+mn-cs"/>
       </a:defRPr>
     </a:lvl6pPr>
-    <a:lvl7pPr marL="2743200" algn="l" defTabSz="914400" rtl="0" eaLnBrk="1" latinLnBrk="0" hangingPunct="1">
+    <a:lvl7pPr marL="2743200" algn="l" defTabSz="457200" rtl="0" eaLnBrk="1" latinLnBrk="0" hangingPunct="1">
       <a:defRPr sz="1200" kern="1200">
         <a:solidFill>
           <a:schemeClr val="tx1"/>
@@ -459,7 +440,7 @@
         <a:cs typeface="+mn-cs"/>
       </a:defRPr>
     </a:lvl7pPr>
-    <a:lvl8pPr marL="3200400" algn="l" defTabSz="914400" rtl="0" eaLnBrk="1" latinLnBrk="0" hangingPunct="1">
+    <a:lvl8pPr marL="3200400" algn="l" defTabSz="457200" rtl="0" eaLnBrk="1" latinLnBrk="0" hangingPunct="1">
       <a:defRPr sz="1200" kern="1200">
         <a:solidFill>
           <a:schemeClr val="tx1"/>
@@ -469,7 +450,7 @@
         <a:cs typeface="+mn-cs"/>
       </a:defRPr>
     </a:lvl8pPr>
-    <a:lvl9pPr marL="3657600" algn="l" defTabSz="914400" rtl="0" eaLnBrk="1" latinLnBrk="0" hangingPunct="1">
+    <a:lvl9pPr marL="3657600" algn="l" defTabSz="457200" rtl="0" eaLnBrk="1" latinLnBrk="0" hangingPunct="1">
       <a:defRPr sz="1200" kern="1200">
         <a:solidFill>
           <a:schemeClr val="tx1"/>
@@ -484,7 +465,7 @@
 </file>
 
 <file path=ppt/notesSlides/notesSlide1.xml><?xml version="1.0" encoding="utf-8"?>
-<p:notes xmlns:a="http://schemas.openxmlformats.org/drawingml/2006/main" xmlns:r="http://schemas.openxmlformats.org/officeDocument/2006/relationships" xmlns:p="http://schemas.openxmlformats.org/presentationml/2006/main">
+<p:notes xmlns:a="http://schemas.openxmlformats.org/drawingml/2006/main" xmlns:p="http://schemas.openxmlformats.org/presentationml/2006/main" xmlns:r="http://schemas.openxmlformats.org/officeDocument/2006/relationships">
   <p:cSld>
     <p:spTree>
       <p:nvGrpSpPr>
@@ -504,7 +485,7 @@
         <p:nvSpPr>
           <p:cNvPr id="2" name="Slide Image Placeholder 1"/>
           <p:cNvSpPr>
-            <a:spLocks noGrp="1" noRot="1" noChangeAspect="1"/>
+            <a:spLocks noGrp="1"/>
           </p:cNvSpPr>
           <p:nvPr>
             <p:ph type="sldImg" idx="2"/>
@@ -519,7 +500,7 @@
             <a:spLocks noGrp="1"/>
           </p:cNvSpPr>
           <p:nvPr>
-            <p:ph type="body" sz="quarter" idx="3"/>
+            <p:ph type="body" idx="3" sz="quarter"/>
           </p:nvPr>
         </p:nvSpPr>
         <p:spPr/>
@@ -531,33 +512,25 @@
               <a:t>How _distinct actually works — two steps, only the first is a byte compare:</a:t>
             </a:r>
           </a:p>
-          <a:p>
-            <a:endParaRPr/>
-          </a:p>
+          <a:p/>
           <a:p>
             <a:r>
               <a:t>1. FIND THE SHARED SKELETON — byte-exact, at line granularity. Split each call's full input into lines; keep the lines byte-identical across EVERY call in the bucket. That is the fixed skeleton (the system config / template). Pure byte comparison.</a:t>
             </a:r>
           </a:p>
-          <a:p>
-            <a:endParaRPr/>
-          </a:p>
+          <a:p/>
           <a:p>
             <a:r>
               <a:t>2. DEDUP THE PER-CALL REMAINDER — fuzzy, by word overlap. For each call take the lines NOT in the skeleton (the per-call variable), turn it into a SET OF WORDS, and treat two calls as the same input when their word sets overlap &gt;= 80% (Jaccard). This MERGES near-duplicates ("refund order 12" vs "...order 12 please") and keeps genuinely different tickets apart. Works from one word up to a paragraph. Deterministic — no embeddings, no ML, no semantics.</a:t>
             </a:r>
           </a:p>
-          <a:p>
-            <a:endParaRPr/>
-          </a:p>
+          <a:p/>
           <a:p>
             <a:r>
               <a:t>WHY word-overlap and not byte compare on the remainder: an exact compare counts every trivially different call as new (a trailing space, a reworded near-dup) and wastes the sample budget; a 3-gram/phrase compare has no shingles for a one-word input, so it falls back to the whole prompt and collapses a simple classifier to 1 input — a false SAFE. Word-set is robust across the whole range.</a:t>
             </a:r>
           </a:p>
-          <a:p>
-            <a:endParaRPr/>
-          </a:p>
+          <a:p/>
           <a:p>
             <a:r>
               <a:t>SAFE BIAS: when we can't tell a real variation from noise (a session id), we keep it. Over-sampling a redundant real input wastes one call; missing a real variation would call a change safe on an input that never exercised it.</a:t>
@@ -572,7 +545,7 @@
             <a:spLocks noGrp="1"/>
           </p:cNvSpPr>
           <p:nvPr>
-            <p:ph type="sldNum" sz="quarter" idx="5"/>
+            <p:ph type="sldNum" idx="5" sz="quarter"/>
           </p:nvPr>
         </p:nvSpPr>
         <p:spPr/>
@@ -623,9 +596,10 @@
           <a:lstStyle/>
           <a:p>
             <a:r>
-              <a:rPr lang="en-US"/>
+              <a:rPr lang="en-US" smtClean="0"/>
               <a:t>Click to edit Master title style</a:t>
             </a:r>
+            <a:endParaRPr lang="en-US"/>
           </a:p>
         </p:txBody>
       </p:sp>
@@ -741,9 +715,10 @@
           </a:lstStyle>
           <a:p>
             <a:r>
-              <a:rPr lang="en-US"/>
+              <a:rPr lang="en-US" smtClean="0"/>
               <a:t>Click to edit Master subtitle style</a:t>
             </a:r>
+            <a:endParaRPr lang="en-US"/>
           </a:p>
         </p:txBody>
       </p:sp>
@@ -764,7 +739,7 @@
           <a:p>
             <a:fld id="{5BCAD085-E8A6-8845-BD4E-CB4CCA059FC4}" type="datetimeFigureOut">
               <a:rPr lang="en-US" smtClean="0"/>
-              <a:t>8/11/2026</a:t>
+              <a:t>1/27/13</a:t>
             </a:fld>
             <a:endParaRPr lang="en-US"/>
           </a:p>
@@ -858,9 +833,10 @@
           <a:lstStyle/>
           <a:p>
             <a:r>
-              <a:rPr lang="en-US"/>
+              <a:rPr lang="en-US" smtClean="0"/>
               <a:t>Click to edit Master title style</a:t>
             </a:r>
+            <a:endParaRPr lang="en-US"/>
           </a:p>
         </p:txBody>
       </p:sp>
@@ -881,37 +857,38 @@
           <a:p>
             <a:pPr lvl="0"/>
             <a:r>
-              <a:rPr lang="en-US"/>
+              <a:rPr lang="en-US" smtClean="0"/>
               <a:t>Click to edit Master text styles</a:t>
             </a:r>
           </a:p>
           <a:p>
             <a:pPr lvl="1"/>
             <a:r>
-              <a:rPr lang="en-US"/>
+              <a:rPr lang="en-US" smtClean="0"/>
               <a:t>Second level</a:t>
             </a:r>
           </a:p>
           <a:p>
             <a:pPr lvl="2"/>
             <a:r>
-              <a:rPr lang="en-US"/>
+              <a:rPr lang="en-US" smtClean="0"/>
               <a:t>Third level</a:t>
             </a:r>
           </a:p>
           <a:p>
             <a:pPr lvl="3"/>
             <a:r>
-              <a:rPr lang="en-US"/>
+              <a:rPr lang="en-US" smtClean="0"/>
               <a:t>Fourth level</a:t>
             </a:r>
           </a:p>
           <a:p>
             <a:pPr lvl="4"/>
             <a:r>
-              <a:rPr lang="en-US"/>
+              <a:rPr lang="en-US" smtClean="0"/>
               <a:t>Fifth level</a:t>
             </a:r>
+            <a:endParaRPr lang="en-US"/>
           </a:p>
         </p:txBody>
       </p:sp>
@@ -932,7 +909,7 @@
           <a:p>
             <a:fld id="{5BCAD085-E8A6-8845-BD4E-CB4CCA059FC4}" type="datetimeFigureOut">
               <a:rPr lang="en-US" smtClean="0"/>
-              <a:t>8/11/2026</a:t>
+              <a:t>1/27/13</a:t>
             </a:fld>
             <a:endParaRPr lang="en-US"/>
           </a:p>
@@ -1031,9 +1008,10 @@
           <a:lstStyle/>
           <a:p>
             <a:r>
-              <a:rPr lang="en-US"/>
+              <a:rPr lang="en-US" smtClean="0"/>
               <a:t>Click to edit Master title style</a:t>
             </a:r>
+            <a:endParaRPr lang="en-US"/>
           </a:p>
         </p:txBody>
       </p:sp>
@@ -1059,37 +1037,38 @@
           <a:p>
             <a:pPr lvl="0"/>
             <a:r>
-              <a:rPr lang="en-US"/>
+              <a:rPr lang="en-US" smtClean="0"/>
               <a:t>Click to edit Master text styles</a:t>
             </a:r>
           </a:p>
           <a:p>
             <a:pPr lvl="1"/>
             <a:r>
-              <a:rPr lang="en-US"/>
+              <a:rPr lang="en-US" smtClean="0"/>
               <a:t>Second level</a:t>
             </a:r>
           </a:p>
           <a:p>
             <a:pPr lvl="2"/>
             <a:r>
-              <a:rPr lang="en-US"/>
+              <a:rPr lang="en-US" smtClean="0"/>
               <a:t>Third level</a:t>
             </a:r>
           </a:p>
           <a:p>
             <a:pPr lvl="3"/>
             <a:r>
-              <a:rPr lang="en-US"/>
+              <a:rPr lang="en-US" smtClean="0"/>
               <a:t>Fourth level</a:t>
             </a:r>
           </a:p>
           <a:p>
             <a:pPr lvl="4"/>
             <a:r>
-              <a:rPr lang="en-US"/>
+              <a:rPr lang="en-US" smtClean="0"/>
               <a:t>Fifth level</a:t>
             </a:r>
+            <a:endParaRPr lang="en-US"/>
           </a:p>
         </p:txBody>
       </p:sp>
@@ -1110,7 +1089,7 @@
           <a:p>
             <a:fld id="{5BCAD085-E8A6-8845-BD4E-CB4CCA059FC4}" type="datetimeFigureOut">
               <a:rPr lang="en-US" smtClean="0"/>
-              <a:t>8/11/2026</a:t>
+              <a:t>1/27/13</a:t>
             </a:fld>
             <a:endParaRPr lang="en-US"/>
           </a:p>
@@ -1204,9 +1183,10 @@
           <a:lstStyle/>
           <a:p>
             <a:r>
-              <a:rPr lang="en-US"/>
+              <a:rPr lang="en-US" smtClean="0"/>
               <a:t>Click to edit Master title style</a:t>
             </a:r>
+            <a:endParaRPr lang="en-US"/>
           </a:p>
         </p:txBody>
       </p:sp>
@@ -1227,37 +1207,38 @@
           <a:p>
             <a:pPr lvl="0"/>
             <a:r>
-              <a:rPr lang="en-US"/>
+              <a:rPr lang="en-US" smtClean="0"/>
               <a:t>Click to edit Master text styles</a:t>
             </a:r>
           </a:p>
           <a:p>
             <a:pPr lvl="1"/>
             <a:r>
-              <a:rPr lang="en-US"/>
+              <a:rPr lang="en-US" smtClean="0"/>
               <a:t>Second level</a:t>
             </a:r>
           </a:p>
           <a:p>
             <a:pPr lvl="2"/>
             <a:r>
-              <a:rPr lang="en-US"/>
+              <a:rPr lang="en-US" smtClean="0"/>
               <a:t>Third level</a:t>
             </a:r>
           </a:p>
           <a:p>
             <a:pPr lvl="3"/>
             <a:r>
-              <a:rPr lang="en-US"/>
+              <a:rPr lang="en-US" smtClean="0"/>
               <a:t>Fourth level</a:t>
             </a:r>
           </a:p>
           <a:p>
             <a:pPr lvl="4"/>
             <a:r>
-              <a:rPr lang="en-US"/>
+              <a:rPr lang="en-US" smtClean="0"/>
               <a:t>Fifth level</a:t>
             </a:r>
+            <a:endParaRPr lang="en-US"/>
           </a:p>
         </p:txBody>
       </p:sp>
@@ -1278,7 +1259,7 @@
           <a:p>
             <a:fld id="{5BCAD085-E8A6-8845-BD4E-CB4CCA059FC4}" type="datetimeFigureOut">
               <a:rPr lang="en-US" smtClean="0"/>
-              <a:t>8/11/2026</a:t>
+              <a:t>1/27/13</a:t>
             </a:fld>
             <a:endParaRPr lang="en-US"/>
           </a:p>
@@ -1381,9 +1362,10 @@
           </a:lstStyle>
           <a:p>
             <a:r>
-              <a:rPr lang="en-US"/>
+              <a:rPr lang="en-US" smtClean="0"/>
               <a:t>Click to edit Master title style</a:t>
             </a:r>
+            <a:endParaRPr lang="en-US"/>
           </a:p>
         </p:txBody>
       </p:sp>
@@ -1500,7 +1482,7 @@
           <a:p>
             <a:pPr lvl="0"/>
             <a:r>
-              <a:rPr lang="en-US"/>
+              <a:rPr lang="en-US" smtClean="0"/>
               <a:t>Click to edit Master text styles</a:t>
             </a:r>
           </a:p>
@@ -1523,7 +1505,7 @@
           <a:p>
             <a:fld id="{5BCAD085-E8A6-8845-BD4E-CB4CCA059FC4}" type="datetimeFigureOut">
               <a:rPr lang="en-US" smtClean="0"/>
-              <a:t>8/11/2026</a:t>
+              <a:t>1/27/13</a:t>
             </a:fld>
             <a:endParaRPr lang="en-US"/>
           </a:p>
@@ -1617,9 +1599,10 @@
           <a:lstStyle/>
           <a:p>
             <a:r>
-              <a:rPr lang="en-US"/>
+              <a:rPr lang="en-US" smtClean="0"/>
               <a:t>Click to edit Master title style</a:t>
             </a:r>
+            <a:endParaRPr lang="en-US"/>
           </a:p>
         </p:txBody>
       </p:sp>
@@ -1673,37 +1656,38 @@
           <a:p>
             <a:pPr lvl="0"/>
             <a:r>
-              <a:rPr lang="en-US"/>
+              <a:rPr lang="en-US" smtClean="0"/>
               <a:t>Click to edit Master text styles</a:t>
             </a:r>
           </a:p>
           <a:p>
             <a:pPr lvl="1"/>
             <a:r>
-              <a:rPr lang="en-US"/>
+              <a:rPr lang="en-US" smtClean="0"/>
               <a:t>Second level</a:t>
             </a:r>
           </a:p>
           <a:p>
             <a:pPr lvl="2"/>
             <a:r>
-              <a:rPr lang="en-US"/>
+              <a:rPr lang="en-US" smtClean="0"/>
               <a:t>Third level</a:t>
             </a:r>
           </a:p>
           <a:p>
             <a:pPr lvl="3"/>
             <a:r>
-              <a:rPr lang="en-US"/>
+              <a:rPr lang="en-US" smtClean="0"/>
               <a:t>Fourth level</a:t>
             </a:r>
           </a:p>
           <a:p>
             <a:pPr lvl="4"/>
             <a:r>
-              <a:rPr lang="en-US"/>
+              <a:rPr lang="en-US" smtClean="0"/>
               <a:t>Fifth level</a:t>
             </a:r>
+            <a:endParaRPr lang="en-US"/>
           </a:p>
         </p:txBody>
       </p:sp>
@@ -1757,37 +1741,38 @@
           <a:p>
             <a:pPr lvl="0"/>
             <a:r>
-              <a:rPr lang="en-US"/>
+              <a:rPr lang="en-US" smtClean="0"/>
               <a:t>Click to edit Master text styles</a:t>
             </a:r>
           </a:p>
           <a:p>
             <a:pPr lvl="1"/>
             <a:r>
-              <a:rPr lang="en-US"/>
+              <a:rPr lang="en-US" smtClean="0"/>
               <a:t>Second level</a:t>
             </a:r>
           </a:p>
           <a:p>
             <a:pPr lvl="2"/>
             <a:r>
-              <a:rPr lang="en-US"/>
+              <a:rPr lang="en-US" smtClean="0"/>
               <a:t>Third level</a:t>
             </a:r>
           </a:p>
           <a:p>
             <a:pPr lvl="3"/>
             <a:r>
-              <a:rPr lang="en-US"/>
+              <a:rPr lang="en-US" smtClean="0"/>
               <a:t>Fourth level</a:t>
             </a:r>
           </a:p>
           <a:p>
             <a:pPr lvl="4"/>
             <a:r>
-              <a:rPr lang="en-US"/>
+              <a:rPr lang="en-US" smtClean="0"/>
               <a:t>Fifth level</a:t>
             </a:r>
+            <a:endParaRPr lang="en-US"/>
           </a:p>
         </p:txBody>
       </p:sp>
@@ -1808,7 +1793,7 @@
           <a:p>
             <a:fld id="{5BCAD085-E8A6-8845-BD4E-CB4CCA059FC4}" type="datetimeFigureOut">
               <a:rPr lang="en-US" smtClean="0"/>
-              <a:t>8/11/2026</a:t>
+              <a:t>1/27/13</a:t>
             </a:fld>
             <a:endParaRPr lang="en-US"/>
           </a:p>
@@ -1906,9 +1891,10 @@
           </a:lstStyle>
           <a:p>
             <a:r>
-              <a:rPr lang="en-US"/>
+              <a:rPr lang="en-US" smtClean="0"/>
               <a:t>Click to edit Master title style</a:t>
             </a:r>
+            <a:endParaRPr lang="en-US"/>
           </a:p>
         </p:txBody>
       </p:sp>
@@ -1971,7 +1957,7 @@
           <a:p>
             <a:pPr lvl="0"/>
             <a:r>
-              <a:rPr lang="en-US"/>
+              <a:rPr lang="en-US" smtClean="0"/>
               <a:t>Click to edit Master text styles</a:t>
             </a:r>
           </a:p>
@@ -2027,37 +2013,38 @@
           <a:p>
             <a:pPr lvl="0"/>
             <a:r>
-              <a:rPr lang="en-US"/>
+              <a:rPr lang="en-US" smtClean="0"/>
               <a:t>Click to edit Master text styles</a:t>
             </a:r>
           </a:p>
           <a:p>
             <a:pPr lvl="1"/>
             <a:r>
-              <a:rPr lang="en-US"/>
+              <a:rPr lang="en-US" smtClean="0"/>
               <a:t>Second level</a:t>
             </a:r>
           </a:p>
           <a:p>
             <a:pPr lvl="2"/>
             <a:r>
-              <a:rPr lang="en-US"/>
+              <a:rPr lang="en-US" smtClean="0"/>
               <a:t>Third level</a:t>
             </a:r>
           </a:p>
           <a:p>
             <a:pPr lvl="3"/>
             <a:r>
-              <a:rPr lang="en-US"/>
+              <a:rPr lang="en-US" smtClean="0"/>
               <a:t>Fourth level</a:t>
             </a:r>
           </a:p>
           <a:p>
             <a:pPr lvl="4"/>
             <a:r>
-              <a:rPr lang="en-US"/>
+              <a:rPr lang="en-US" smtClean="0"/>
               <a:t>Fifth level</a:t>
             </a:r>
+            <a:endParaRPr lang="en-US"/>
           </a:p>
         </p:txBody>
       </p:sp>
@@ -2120,7 +2107,7 @@
           <a:p>
             <a:pPr lvl="0"/>
             <a:r>
-              <a:rPr lang="en-US"/>
+              <a:rPr lang="en-US" smtClean="0"/>
               <a:t>Click to edit Master text styles</a:t>
             </a:r>
           </a:p>
@@ -2176,37 +2163,38 @@
           <a:p>
             <a:pPr lvl="0"/>
             <a:r>
-              <a:rPr lang="en-US"/>
+              <a:rPr lang="en-US" smtClean="0"/>
               <a:t>Click to edit Master text styles</a:t>
             </a:r>
           </a:p>
           <a:p>
             <a:pPr lvl="1"/>
             <a:r>
-              <a:rPr lang="en-US"/>
+              <a:rPr lang="en-US" smtClean="0"/>
               <a:t>Second level</a:t>
             </a:r>
           </a:p>
           <a:p>
             <a:pPr lvl="2"/>
             <a:r>
-              <a:rPr lang="en-US"/>
+              <a:rPr lang="en-US" smtClean="0"/>
               <a:t>Third level</a:t>
             </a:r>
           </a:p>
           <a:p>
             <a:pPr lvl="3"/>
             <a:r>
-              <a:rPr lang="en-US"/>
+              <a:rPr lang="en-US" smtClean="0"/>
               <a:t>Fourth level</a:t>
             </a:r>
           </a:p>
           <a:p>
             <a:pPr lvl="4"/>
             <a:r>
-              <a:rPr lang="en-US"/>
+              <a:rPr lang="en-US" smtClean="0"/>
               <a:t>Fifth level</a:t>
             </a:r>
+            <a:endParaRPr lang="en-US"/>
           </a:p>
         </p:txBody>
       </p:sp>
@@ -2227,7 +2215,7 @@
           <a:p>
             <a:fld id="{5BCAD085-E8A6-8845-BD4E-CB4CCA059FC4}" type="datetimeFigureOut">
               <a:rPr lang="en-US" smtClean="0"/>
-              <a:t>8/11/2026</a:t>
+              <a:t>1/27/13</a:t>
             </a:fld>
             <a:endParaRPr lang="en-US"/>
           </a:p>
@@ -2321,9 +2309,10 @@
           <a:lstStyle/>
           <a:p>
             <a:r>
-              <a:rPr lang="en-US"/>
+              <a:rPr lang="en-US" smtClean="0"/>
               <a:t>Click to edit Master title style</a:t>
             </a:r>
+            <a:endParaRPr lang="en-US"/>
           </a:p>
         </p:txBody>
       </p:sp>
@@ -2344,7 +2333,7 @@
           <a:p>
             <a:fld id="{5BCAD085-E8A6-8845-BD4E-CB4CCA059FC4}" type="datetimeFigureOut">
               <a:rPr lang="en-US" smtClean="0"/>
-              <a:t>8/11/2026</a:t>
+              <a:t>1/27/13</a:t>
             </a:fld>
             <a:endParaRPr lang="en-US"/>
           </a:p>
@@ -2439,7 +2428,7 @@
           <a:p>
             <a:fld id="{5BCAD085-E8A6-8845-BD4E-CB4CCA059FC4}" type="datetimeFigureOut">
               <a:rPr lang="en-US" smtClean="0"/>
-              <a:t>8/11/2026</a:t>
+              <a:t>1/27/13</a:t>
             </a:fld>
             <a:endParaRPr lang="en-US"/>
           </a:p>
@@ -2542,9 +2531,10 @@
           </a:lstStyle>
           <a:p>
             <a:r>
-              <a:rPr lang="en-US"/>
+              <a:rPr lang="en-US" smtClean="0"/>
               <a:t>Click to edit Master title style</a:t>
             </a:r>
+            <a:endParaRPr lang="en-US"/>
           </a:p>
         </p:txBody>
       </p:sp>
@@ -2598,37 +2588,38 @@
           <a:p>
             <a:pPr lvl="0"/>
             <a:r>
-              <a:rPr lang="en-US"/>
+              <a:rPr lang="en-US" smtClean="0"/>
               <a:t>Click to edit Master text styles</a:t>
             </a:r>
           </a:p>
           <a:p>
             <a:pPr lvl="1"/>
             <a:r>
-              <a:rPr lang="en-US"/>
+              <a:rPr lang="en-US" smtClean="0"/>
               <a:t>Second level</a:t>
             </a:r>
           </a:p>
           <a:p>
             <a:pPr lvl="2"/>
             <a:r>
-              <a:rPr lang="en-US"/>
+              <a:rPr lang="en-US" smtClean="0"/>
               <a:t>Third level</a:t>
             </a:r>
           </a:p>
           <a:p>
             <a:pPr lvl="3"/>
             <a:r>
-              <a:rPr lang="en-US"/>
+              <a:rPr lang="en-US" smtClean="0"/>
               <a:t>Fourth level</a:t>
             </a:r>
           </a:p>
           <a:p>
             <a:pPr lvl="4"/>
             <a:r>
-              <a:rPr lang="en-US"/>
+              <a:rPr lang="en-US" smtClean="0"/>
               <a:t>Fifth level</a:t>
             </a:r>
+            <a:endParaRPr lang="en-US"/>
           </a:p>
         </p:txBody>
       </p:sp>
@@ -2691,7 +2682,7 @@
           <a:p>
             <a:pPr lvl="0"/>
             <a:r>
-              <a:rPr lang="en-US"/>
+              <a:rPr lang="en-US" smtClean="0"/>
               <a:t>Click to edit Master text styles</a:t>
             </a:r>
           </a:p>
@@ -2714,7 +2705,7 @@
           <a:p>
             <a:fld id="{5BCAD085-E8A6-8845-BD4E-CB4CCA059FC4}" type="datetimeFigureOut">
               <a:rPr lang="en-US" smtClean="0"/>
-              <a:t>8/11/2026</a:t>
+              <a:t>1/27/13</a:t>
             </a:fld>
             <a:endParaRPr lang="en-US"/>
           </a:p>
@@ -2817,9 +2808,10 @@
           </a:lstStyle>
           <a:p>
             <a:r>
-              <a:rPr lang="en-US"/>
+              <a:rPr lang="en-US" smtClean="0"/>
               <a:t>Click to edit Master title style</a:t>
             </a:r>
+            <a:endParaRPr lang="en-US"/>
           </a:p>
         </p:txBody>
       </p:sp>
@@ -2943,7 +2935,7 @@
           <a:p>
             <a:pPr lvl="0"/>
             <a:r>
-              <a:rPr lang="en-US"/>
+              <a:rPr lang="en-US" smtClean="0"/>
               <a:t>Click to edit Master text styles</a:t>
             </a:r>
           </a:p>
@@ -2966,7 +2958,7 @@
           <a:p>
             <a:fld id="{5BCAD085-E8A6-8845-BD4E-CB4CCA059FC4}" type="datetimeFigureOut">
               <a:rPr lang="en-US" smtClean="0"/>
-              <a:t>8/11/2026</a:t>
+              <a:t>1/27/13</a:t>
             </a:fld>
             <a:endParaRPr lang="en-US"/>
           </a:p>
@@ -3075,9 +3067,10 @@
           <a:lstStyle/>
           <a:p>
             <a:r>
-              <a:rPr lang="en-US"/>
+              <a:rPr lang="en-US" smtClean="0"/>
               <a:t>Click to edit Master title style</a:t>
             </a:r>
+            <a:endParaRPr lang="en-US"/>
           </a:p>
         </p:txBody>
       </p:sp>
@@ -3108,37 +3101,38 @@
           <a:p>
             <a:pPr lvl="0"/>
             <a:r>
-              <a:rPr lang="en-US"/>
+              <a:rPr lang="en-US" smtClean="0"/>
               <a:t>Click to edit Master text styles</a:t>
             </a:r>
           </a:p>
           <a:p>
             <a:pPr lvl="1"/>
             <a:r>
-              <a:rPr lang="en-US"/>
+              <a:rPr lang="en-US" smtClean="0"/>
               <a:t>Second level</a:t>
             </a:r>
           </a:p>
           <a:p>
             <a:pPr lvl="2"/>
             <a:r>
-              <a:rPr lang="en-US"/>
+              <a:rPr lang="en-US" smtClean="0"/>
               <a:t>Third level</a:t>
             </a:r>
           </a:p>
           <a:p>
             <a:pPr lvl="3"/>
             <a:r>
-              <a:rPr lang="en-US"/>
+              <a:rPr lang="en-US" smtClean="0"/>
               <a:t>Fourth level</a:t>
             </a:r>
           </a:p>
           <a:p>
             <a:pPr lvl="4"/>
             <a:r>
-              <a:rPr lang="en-US"/>
+              <a:rPr lang="en-US" smtClean="0"/>
               <a:t>Fifth level</a:t>
             </a:r>
+            <a:endParaRPr lang="en-US"/>
           </a:p>
         </p:txBody>
       </p:sp>
@@ -3177,7 +3171,7 @@
           <a:p>
             <a:fld id="{5BCAD085-E8A6-8845-BD4E-CB4CCA059FC4}" type="datetimeFigureOut">
               <a:rPr lang="en-US" smtClean="0"/>
-              <a:t>8/11/2026</a:t>
+              <a:t>1/27/13</a:t>
             </a:fld>
             <a:endParaRPr lang="en-US"/>
           </a:p>
@@ -3536,7 +3530,7 @@
 </file>
 
 <file path=ppt/slides/slide1.xml><?xml version="1.0" encoding="utf-8"?>
-<p:sld xmlns:a="http://schemas.openxmlformats.org/drawingml/2006/main" xmlns:r="http://schemas.openxmlformats.org/officeDocument/2006/relationships" xmlns:p="http://schemas.openxmlformats.org/presentationml/2006/main">
+<p:sld xmlns:a="http://schemas.openxmlformats.org/drawingml/2006/main" xmlns:p="http://schemas.openxmlformats.org/presentationml/2006/main" xmlns:r="http://schemas.openxmlformats.org/officeDocument/2006/relationships">
   <p:cSld>
     <p:bg>
       <p:bgPr>
@@ -3552,14 +3546,7 @@
         <p:cNvGrpSpPr/>
         <p:nvPr/>
       </p:nvGrpSpPr>
-      <p:grpSpPr>
-        <a:xfrm>
-          <a:off x="0" y="0"/>
-          <a:ext cx="0" cy="0"/>
-          <a:chOff x="0" y="0"/>
-          <a:chExt cx="0" cy="0"/>
-        </a:xfrm>
-      </p:grpSpPr>
+      <p:grpSpPr/>
       <p:sp>
         <p:nvSpPr>
           <p:cNvPr id="2" name="Rectangle 1"/>
@@ -3601,7 +3588,6 @@
           <a:lstStyle/>
           <a:p>
             <a:pPr algn="ctr"/>
-            <a:endParaRPr/>
           </a:p>
         </p:txBody>
       </p:sp>
@@ -3622,7 +3608,7 @@
           <a:noFill/>
         </p:spPr>
         <p:txBody>
-          <a:bodyPr wrap="square" lIns="0" tIns="0" rIns="0" bIns="0" anchor="t">
+          <a:bodyPr wrap="square" anchor="t" lIns="0" rIns="0" tIns="0" bIns="0">
             <a:spAutoFit/>
           </a:bodyPr>
           <a:lstStyle/>
@@ -3657,7 +3643,7 @@
           <a:noFill/>
         </p:spPr>
         <p:txBody>
-          <a:bodyPr wrap="square" lIns="0" tIns="0" rIns="0" bIns="0" anchor="t">
+          <a:bodyPr wrap="square" anchor="t" lIns="0" rIns="0" tIns="0" bIns="0">
             <a:spAutoFit/>
           </a:bodyPr>
           <a:lstStyle/>
@@ -3692,7 +3678,7 @@
           <a:noFill/>
         </p:spPr>
         <p:txBody>
-          <a:bodyPr wrap="square" lIns="0" tIns="0" rIns="0" bIns="0" anchor="t">
+          <a:bodyPr wrap="square" anchor="t" lIns="0" rIns="0" tIns="0" bIns="0">
             <a:spAutoFit/>
           </a:bodyPr>
           <a:lstStyle/>
@@ -3727,7 +3713,7 @@
           <a:noFill/>
         </p:spPr>
         <p:txBody>
-          <a:bodyPr wrap="square" lIns="0" tIns="0" rIns="0" bIns="0" anchor="t">
+          <a:bodyPr wrap="square" anchor="t" lIns="0" rIns="0" tIns="0" bIns="0">
             <a:spAutoFit/>
           </a:bodyPr>
           <a:lstStyle/>
@@ -3762,7 +3748,7 @@
           <a:noFill/>
         </p:spPr>
         <p:txBody>
-          <a:bodyPr wrap="square" lIns="0" tIns="0" rIns="0" bIns="0" anchor="t">
+          <a:bodyPr wrap="square" anchor="t" lIns="0" rIns="0" tIns="0" bIns="0">
             <a:spAutoFit/>
           </a:bodyPr>
           <a:lstStyle/>
@@ -3841,7 +3827,6 @@
           <a:lstStyle/>
           <a:p>
             <a:pPr algn="ctr"/>
-            <a:endParaRPr/>
           </a:p>
         </p:txBody>
       </p:sp>
@@ -3886,7 +3871,6 @@
           <a:lstStyle/>
           <a:p>
             <a:pPr algn="ctr"/>
-            <a:endParaRPr/>
           </a:p>
         </p:txBody>
       </p:sp>
@@ -3907,7 +3891,7 @@
           <a:noFill/>
         </p:spPr>
         <p:txBody>
-          <a:bodyPr wrap="square" lIns="0" tIns="0" rIns="0" bIns="0" anchor="t">
+          <a:bodyPr wrap="square" anchor="t" lIns="0" rIns="0" tIns="0" bIns="0">
             <a:spAutoFit/>
           </a:bodyPr>
           <a:lstStyle/>
@@ -3986,7 +3970,6 @@
           <a:lstStyle/>
           <a:p>
             <a:pPr algn="ctr"/>
-            <a:endParaRPr/>
           </a:p>
         </p:txBody>
       </p:sp>
@@ -4007,7 +3990,7 @@
           <a:noFill/>
         </p:spPr>
         <p:txBody>
-          <a:bodyPr wrap="square" lIns="0" tIns="0" rIns="0" bIns="0" anchor="t">
+          <a:bodyPr wrap="square" anchor="t" lIns="0" rIns="0" tIns="0" bIns="0">
             <a:spAutoFit/>
           </a:bodyPr>
           <a:lstStyle/>
@@ -4066,7 +4049,6 @@
           <a:lstStyle/>
           <a:p>
             <a:pPr algn="ctr"/>
-            <a:endParaRPr/>
           </a:p>
         </p:txBody>
       </p:sp>
@@ -4087,7 +4069,7 @@
           <a:noFill/>
         </p:spPr>
         <p:txBody>
-          <a:bodyPr wrap="square" lIns="0" tIns="0" rIns="0" bIns="0" anchor="t">
+          <a:bodyPr wrap="square" anchor="t" lIns="0" rIns="0" tIns="0" bIns="0">
             <a:spAutoFit/>
           </a:bodyPr>
           <a:lstStyle/>
@@ -4122,7 +4104,7 @@
           <a:noFill/>
         </p:spPr>
         <p:txBody>
-          <a:bodyPr wrap="square" lIns="0" tIns="0" rIns="0" bIns="0" anchor="t">
+          <a:bodyPr wrap="square" anchor="t" lIns="0" rIns="0" tIns="0" bIns="0">
             <a:spAutoFit/>
           </a:bodyPr>
           <a:lstStyle/>
@@ -4201,7 +4183,6 @@
           <a:lstStyle/>
           <a:p>
             <a:pPr algn="ctr"/>
-            <a:endParaRPr/>
           </a:p>
         </p:txBody>
       </p:sp>
@@ -4222,7 +4203,7 @@
           <a:noFill/>
         </p:spPr>
         <p:txBody>
-          <a:bodyPr wrap="square" lIns="0" tIns="0" rIns="0" bIns="0" anchor="t">
+          <a:bodyPr wrap="square" anchor="t" lIns="0" rIns="0" tIns="0" bIns="0">
             <a:spAutoFit/>
           </a:bodyPr>
           <a:lstStyle/>
@@ -4257,7 +4238,7 @@
           <a:noFill/>
         </p:spPr>
         <p:txBody>
-          <a:bodyPr wrap="square" lIns="0" tIns="0" rIns="0" bIns="0" anchor="t">
+          <a:bodyPr wrap="square" anchor="t" lIns="0" rIns="0" tIns="0" bIns="0">
             <a:spAutoFit/>
           </a:bodyPr>
           <a:lstStyle/>
@@ -4336,7 +4317,6 @@
           <a:lstStyle/>
           <a:p>
             <a:pPr algn="ctr"/>
-            <a:endParaRPr/>
           </a:p>
         </p:txBody>
       </p:sp>
@@ -4357,7 +4337,7 @@
           <a:noFill/>
         </p:spPr>
         <p:txBody>
-          <a:bodyPr wrap="square" lIns="0" tIns="0" rIns="0" bIns="0" anchor="t">
+          <a:bodyPr wrap="square" anchor="t" lIns="0" rIns="0" tIns="0" bIns="0">
             <a:spAutoFit/>
           </a:bodyPr>
           <a:lstStyle/>
@@ -4392,7 +4372,7 @@
           <a:noFill/>
         </p:spPr>
         <p:txBody>
-          <a:bodyPr wrap="square" lIns="0" tIns="0" rIns="0" bIns="0" anchor="t">
+          <a:bodyPr wrap="square" anchor="t" lIns="0" rIns="0" tIns="0" bIns="0">
             <a:spAutoFit/>
           </a:bodyPr>
           <a:lstStyle/>
@@ -4471,7 +4451,6 @@
           <a:lstStyle/>
           <a:p>
             <a:pPr algn="ctr"/>
-            <a:endParaRPr/>
           </a:p>
         </p:txBody>
       </p:sp>
@@ -4492,7 +4471,7 @@
           <a:noFill/>
         </p:spPr>
         <p:txBody>
-          <a:bodyPr wrap="square" lIns="0" tIns="0" rIns="0" bIns="0" anchor="t">
+          <a:bodyPr wrap="square" anchor="t" lIns="0" rIns="0" tIns="0" bIns="0">
             <a:spAutoFit/>
           </a:bodyPr>
           <a:lstStyle/>
@@ -4527,7 +4506,7 @@
           <a:noFill/>
         </p:spPr>
         <p:txBody>
-          <a:bodyPr wrap="square" lIns="0" tIns="0" rIns="0" bIns="0" anchor="t">
+          <a:bodyPr wrap="square" anchor="t" lIns="0" rIns="0" tIns="0" bIns="0">
             <a:spAutoFit/>
           </a:bodyPr>
           <a:lstStyle/>
@@ -4606,7 +4585,6 @@
           <a:lstStyle/>
           <a:p>
             <a:pPr algn="ctr"/>
-            <a:endParaRPr/>
           </a:p>
         </p:txBody>
       </p:sp>
@@ -4627,7 +4605,7 @@
           <a:noFill/>
         </p:spPr>
         <p:txBody>
-          <a:bodyPr wrap="square" lIns="0" tIns="0" rIns="0" bIns="0" anchor="t">
+          <a:bodyPr wrap="square" anchor="t" lIns="0" rIns="0" tIns="0" bIns="0">
             <a:spAutoFit/>
           </a:bodyPr>
           <a:lstStyle/>
@@ -4662,7 +4640,7 @@
           <a:noFill/>
         </p:spPr>
         <p:txBody>
-          <a:bodyPr wrap="square" lIns="0" tIns="0" rIns="0" bIns="0" anchor="t">
+          <a:bodyPr wrap="square" anchor="t" lIns="0" rIns="0" tIns="0" bIns="0">
             <a:spAutoFit/>
           </a:bodyPr>
           <a:lstStyle/>
@@ -4717,7 +4695,7 @@
           <a:noFill/>
         </p:spPr>
         <p:txBody>
-          <a:bodyPr wrap="square" lIns="0" tIns="0" rIns="0" bIns="0" anchor="t">
+          <a:bodyPr wrap="square" anchor="t" lIns="0" rIns="0" tIns="0" bIns="0">
             <a:spAutoFit/>
           </a:bodyPr>
           <a:lstStyle/>
@@ -4772,7 +4750,7 @@
           <a:noFill/>
         </p:spPr>
         <p:txBody>
-          <a:bodyPr wrap="square" lIns="0" tIns="0" rIns="0" bIns="0" anchor="t">
+          <a:bodyPr wrap="square" anchor="t" lIns="0" rIns="0" tIns="0" bIns="0">
             <a:spAutoFit/>
           </a:bodyPr>
           <a:lstStyle/>
@@ -4819,7 +4797,7 @@
 </file>
 
 <file path=ppt/slides/slide2.xml><?xml version="1.0" encoding="utf-8"?>
-<p:sld xmlns:a="http://schemas.openxmlformats.org/drawingml/2006/main" xmlns:r="http://schemas.openxmlformats.org/officeDocument/2006/relationships" xmlns:p="http://schemas.openxmlformats.org/presentationml/2006/main">
+<p:sld xmlns:a="http://schemas.openxmlformats.org/drawingml/2006/main" xmlns:p="http://schemas.openxmlformats.org/presentationml/2006/main" xmlns:r="http://schemas.openxmlformats.org/officeDocument/2006/relationships">
   <p:cSld>
     <p:bg>
       <p:bgPr>
@@ -4835,14 +4813,7 @@
         <p:cNvGrpSpPr/>
         <p:nvPr/>
       </p:nvGrpSpPr>
-      <p:grpSpPr>
-        <a:xfrm>
-          <a:off x="0" y="0"/>
-          <a:ext cx="0" cy="0"/>
-          <a:chOff x="0" y="0"/>
-          <a:chExt cx="0" cy="0"/>
-        </a:xfrm>
-      </p:grpSpPr>
+      <p:grpSpPr/>
       <p:sp>
         <p:nvSpPr>
           <p:cNvPr id="2" name="Rectangle 1"/>
@@ -4884,7 +4855,6 @@
           <a:lstStyle/>
           <a:p>
             <a:pPr algn="ctr"/>
-            <a:endParaRPr/>
           </a:p>
         </p:txBody>
       </p:sp>
@@ -4905,7 +4875,7 @@
           <a:noFill/>
         </p:spPr>
         <p:txBody>
-          <a:bodyPr wrap="square" lIns="0" tIns="0" rIns="0" bIns="0" anchor="t">
+          <a:bodyPr wrap="square" anchor="t" lIns="0" rIns="0" tIns="0" bIns="0">
             <a:spAutoFit/>
           </a:bodyPr>
           <a:lstStyle/>
@@ -4940,7 +4910,7 @@
           <a:noFill/>
         </p:spPr>
         <p:txBody>
-          <a:bodyPr wrap="square" lIns="0" tIns="0" rIns="0" bIns="0" anchor="t">
+          <a:bodyPr wrap="square" anchor="t" lIns="0" rIns="0" tIns="0" bIns="0">
             <a:spAutoFit/>
           </a:bodyPr>
           <a:lstStyle/>
@@ -4975,7 +4945,7 @@
           <a:noFill/>
         </p:spPr>
         <p:txBody>
-          <a:bodyPr wrap="square" lIns="0" tIns="0" rIns="0" bIns="0" anchor="t">
+          <a:bodyPr wrap="square" anchor="t" lIns="0" rIns="0" tIns="0" bIns="0">
             <a:spAutoFit/>
           </a:bodyPr>
           <a:lstStyle/>
@@ -5010,7 +4980,7 @@
           <a:noFill/>
         </p:spPr>
         <p:txBody>
-          <a:bodyPr wrap="square" lIns="0" tIns="0" rIns="0" bIns="0" anchor="t">
+          <a:bodyPr wrap="square" anchor="t" lIns="0" rIns="0" tIns="0" bIns="0">
             <a:spAutoFit/>
           </a:bodyPr>
           <a:lstStyle/>
@@ -5069,7 +5039,6 @@
           <a:lstStyle/>
           <a:p>
             <a:pPr algn="ctr"/>
-            <a:endParaRPr/>
           </a:p>
         </p:txBody>
       </p:sp>
@@ -5090,7 +5059,7 @@
           <a:noFill/>
         </p:spPr>
         <p:txBody>
-          <a:bodyPr wrap="square" lIns="0" tIns="0" rIns="0" bIns="0" anchor="t">
+          <a:bodyPr wrap="square" anchor="t" lIns="0" rIns="0" tIns="0" bIns="0">
             <a:spAutoFit/>
           </a:bodyPr>
           <a:lstStyle/>
@@ -5125,7 +5094,7 @@
           <a:noFill/>
         </p:spPr>
         <p:txBody>
-          <a:bodyPr wrap="square" lIns="0" tIns="0" rIns="0" bIns="0" anchor="t">
+          <a:bodyPr wrap="square" anchor="t" lIns="0" rIns="0" tIns="0" bIns="0">
             <a:spAutoFit/>
           </a:bodyPr>
           <a:lstStyle/>
@@ -5182,7 +5151,7 @@
           </a:fontRef>
         </p:style>
         <p:txBody>
-          <a:bodyPr wrap="square" lIns="73152" tIns="27432" rIns="73152" bIns="27432" rtlCol="0" anchor="ctr"/>
+          <a:bodyPr rtlCol="0" anchor="ctr" wrap="square" lIns="73152" rIns="73152" tIns="27432" bIns="27432"/>
           <a:lstStyle/>
           <a:p>
             <a:pPr algn="l"/>
@@ -5237,7 +5206,7 @@
           </a:fontRef>
         </p:style>
         <p:txBody>
-          <a:bodyPr wrap="square" lIns="73152" tIns="27432" rIns="73152" bIns="27432" rtlCol="0" anchor="ctr"/>
+          <a:bodyPr rtlCol="0" anchor="ctr" wrap="square" lIns="73152" rIns="73152" tIns="27432" bIns="27432"/>
           <a:lstStyle/>
           <a:p>
             <a:pPr algn="ctr"/>
@@ -5292,7 +5261,7 @@
           </a:fontRef>
         </p:style>
         <p:txBody>
-          <a:bodyPr wrap="square" lIns="73152" tIns="27432" rIns="73152" bIns="27432" rtlCol="0" anchor="ctr"/>
+          <a:bodyPr rtlCol="0" anchor="ctr" wrap="square" lIns="73152" rIns="73152" tIns="27432" bIns="27432"/>
           <a:lstStyle/>
           <a:p>
             <a:pPr algn="l"/>
@@ -5303,7 +5272,7 @@
                 </a:solidFill>
                 <a:latin typeface="Segoe UI"/>
               </a:rPr>
-              <a:t>5 genuinely different real inputs, re-run 3× each and judged</a:t>
+              <a:t>5 genuinely different real inputs, cheaper re-run 5× and</a:t>
             </a:r>
           </a:p>
           <a:p>
@@ -5315,7 +5284,7 @@
                 </a:solidFill>
                 <a:latin typeface="Segoe UI"/>
               </a:rPr>
-              <a:t>against your own recorded output</a:t>
+              <a:t>majority-judged against your model's own 5 outputs</a:t>
             </a:r>
           </a:p>
         </p:txBody>
@@ -5359,7 +5328,7 @@
           </a:fontRef>
         </p:style>
         <p:txBody>
-          <a:bodyPr wrap="square" lIns="73152" tIns="27432" rIns="73152" bIns="27432" rtlCol="0" anchor="ctr"/>
+          <a:bodyPr rtlCol="0" anchor="ctr" wrap="square" lIns="73152" rIns="73152" tIns="27432" bIns="27432"/>
           <a:lstStyle/>
           <a:p>
             <a:pPr algn="l"/>
@@ -5414,7 +5383,7 @@
           </a:fontRef>
         </p:style>
         <p:txBody>
-          <a:bodyPr wrap="square" lIns="73152" tIns="27432" rIns="73152" bIns="27432" rtlCol="0" anchor="ctr"/>
+          <a:bodyPr rtlCol="0" anchor="ctr" wrap="square" lIns="73152" rIns="73152" tIns="27432" bIns="27432"/>
           <a:lstStyle/>
           <a:p>
             <a:pPr algn="ctr"/>
@@ -5469,7 +5438,7 @@
           </a:fontRef>
         </p:style>
         <p:txBody>
-          <a:bodyPr wrap="square" lIns="73152" tIns="27432" rIns="73152" bIns="27432" rtlCol="0" anchor="ctr"/>
+          <a:bodyPr rtlCol="0" anchor="ctr" wrap="square" lIns="73152" rIns="73152" tIns="27432" bIns="27432"/>
           <a:lstStyle/>
           <a:p>
             <a:pPr algn="l"/>
@@ -5536,7 +5505,7 @@
           </a:fontRef>
         </p:style>
         <p:txBody>
-          <a:bodyPr wrap="square" lIns="73152" tIns="27432" rIns="73152" bIns="27432" rtlCol="0" anchor="ctr"/>
+          <a:bodyPr rtlCol="0" anchor="ctr" wrap="square" lIns="73152" rIns="73152" tIns="27432" bIns="27432"/>
           <a:lstStyle/>
           <a:p>
             <a:pPr algn="l"/>
@@ -5591,7 +5560,7 @@
           </a:fontRef>
         </p:style>
         <p:txBody>
-          <a:bodyPr wrap="square" lIns="73152" tIns="27432" rIns="73152" bIns="27432" rtlCol="0" anchor="ctr"/>
+          <a:bodyPr rtlCol="0" anchor="ctr" wrap="square" lIns="73152" rIns="73152" tIns="27432" bIns="27432"/>
           <a:lstStyle/>
           <a:p>
             <a:pPr algn="ctr"/>
@@ -5646,7 +5615,7 @@
           </a:fontRef>
         </p:style>
         <p:txBody>
-          <a:bodyPr wrap="square" lIns="73152" tIns="27432" rIns="73152" bIns="27432" rtlCol="0" anchor="ctr"/>
+          <a:bodyPr rtlCol="0" anchor="ctr" wrap="square" lIns="73152" rIns="73152" tIns="27432" bIns="27432"/>
           <a:lstStyle/>
           <a:p>
             <a:pPr algn="l"/>
@@ -5705,7 +5674,6 @@
           <a:lstStyle/>
           <a:p>
             <a:pPr algn="ctr"/>
-            <a:endParaRPr/>
           </a:p>
         </p:txBody>
       </p:sp>
@@ -5726,7 +5694,7 @@
           <a:noFill/>
         </p:spPr>
         <p:txBody>
-          <a:bodyPr wrap="square" lIns="0" tIns="0" rIns="0" bIns="0" anchor="t">
+          <a:bodyPr wrap="square" anchor="t" lIns="0" rIns="0" tIns="0" bIns="0">
             <a:spAutoFit/>
           </a:bodyPr>
           <a:lstStyle/>
@@ -5761,7 +5729,7 @@
           <a:noFill/>
         </p:spPr>
         <p:txBody>
-          <a:bodyPr wrap="square" lIns="0" tIns="0" rIns="0" bIns="0" anchor="t">
+          <a:bodyPr wrap="square" anchor="t" lIns="0" rIns="0" tIns="0" bIns="0">
             <a:spAutoFit/>
           </a:bodyPr>
           <a:lstStyle/>
@@ -5820,7 +5788,6 @@
           <a:lstStyle/>
           <a:p>
             <a:pPr algn="ctr"/>
-            <a:endParaRPr/>
           </a:p>
         </p:txBody>
       </p:sp>
@@ -5841,7 +5808,7 @@
           <a:noFill/>
         </p:spPr>
         <p:txBody>
-          <a:bodyPr wrap="square" lIns="0" tIns="0" rIns="0" bIns="0" anchor="t">
+          <a:bodyPr wrap="square" anchor="t" lIns="0" rIns="0" tIns="0" bIns="0">
             <a:spAutoFit/>
           </a:bodyPr>
           <a:lstStyle/>
@@ -5876,7 +5843,7 @@
           <a:noFill/>
         </p:spPr>
         <p:txBody>
-          <a:bodyPr wrap="square" lIns="0" tIns="0" rIns="0" bIns="0" anchor="t">
+          <a:bodyPr wrap="square" anchor="t" lIns="0" rIns="0" tIns="0" bIns="0">
             <a:spAutoFit/>
           </a:bodyPr>
           <a:lstStyle/>
@@ -5931,7 +5898,7 @@
           <a:noFill/>
         </p:spPr>
         <p:txBody>
-          <a:bodyPr wrap="square" lIns="0" tIns="0" rIns="0" bIns="0" anchor="t">
+          <a:bodyPr wrap="square" anchor="t" lIns="0" rIns="0" tIns="0" bIns="0">
             <a:spAutoFit/>
           </a:bodyPr>
           <a:lstStyle/>
@@ -5986,7 +5953,7 @@
           <a:noFill/>
         </p:spPr>
         <p:txBody>
-          <a:bodyPr wrap="square" lIns="0" tIns="0" rIns="0" bIns="0" anchor="t">
+          <a:bodyPr wrap="square" anchor="t" lIns="0" rIns="0" tIns="0" bIns="0">
             <a:spAutoFit/>
           </a:bodyPr>
           <a:lstStyle/>
@@ -6003,7 +5970,7 @@
                 </a:solidFill>
                 <a:latin typeface="Segoe UI"/>
               </a:rPr>
-              <a:t>Unanimous, or it earns nothing</a:t>
+              <a:t>Every verdict is a majority vote</a:t>
             </a:r>
           </a:p>
           <a:p>
@@ -6019,7 +5986,7 @@
                 </a:solidFill>
                 <a:latin typeface="Segoe UI"/>
               </a:rPr>
-              <a:t>One drifting input pulls the whole call-site out of the total. Split results are reported and counted as zero.</a:t>
+              <a:t>Each output is judged several times and the majority wins, so one stray judge call can't flip the result; the cheaper must fit as often as the original fits itself.</a:t>
             </a:r>
           </a:p>
         </p:txBody>
@@ -6065,7 +6032,6 @@
           <a:lstStyle/>
           <a:p>
             <a:pPr algn="ctr"/>
-            <a:endParaRPr/>
           </a:p>
         </p:txBody>
       </p:sp>
@@ -6086,7 +6052,7 @@
           <a:noFill/>
         </p:spPr>
         <p:txBody>
-          <a:bodyPr wrap="square" lIns="0" tIns="0" rIns="0" bIns="0" anchor="t">
+          <a:bodyPr wrap="square" anchor="t" lIns="0" rIns="0" tIns="0" bIns="0">
             <a:spAutoFit/>
           </a:bodyPr>
           <a:lstStyle/>
@@ -6121,7 +6087,7 @@
           <a:noFill/>
         </p:spPr>
         <p:txBody>
-          <a:bodyPr wrap="square" lIns="0" tIns="0" rIns="0" bIns="0" anchor="t">
+          <a:bodyPr wrap="square" anchor="t" lIns="0" rIns="0" tIns="0" bIns="0">
             <a:spAutoFit/>
           </a:bodyPr>
           <a:lstStyle/>
@@ -6176,7 +6142,7 @@
           <a:noFill/>
         </p:spPr>
         <p:txBody>
-          <a:bodyPr wrap="square" lIns="0" tIns="0" rIns="0" bIns="0" anchor="t">
+          <a:bodyPr wrap="square" anchor="t" lIns="0" rIns="0" tIns="0" bIns="0">
             <a:spAutoFit/>
           </a:bodyPr>
           <a:lstStyle/>
@@ -6231,7 +6197,7 @@
           <a:noFill/>
         </p:spPr>
         <p:txBody>
-          <a:bodyPr wrap="square" lIns="0" tIns="0" rIns="0" bIns="0" anchor="t">
+          <a:bodyPr wrap="square" anchor="t" lIns="0" rIns="0" tIns="0" bIns="0">
             <a:spAutoFit/>
           </a:bodyPr>
           <a:lstStyle/>
@@ -6278,7 +6244,7 @@
 </file>
 
 <file path=ppt/slides/slide3.xml><?xml version="1.0" encoding="utf-8"?>
-<p:sld xmlns:a="http://schemas.openxmlformats.org/drawingml/2006/main" xmlns:r="http://schemas.openxmlformats.org/officeDocument/2006/relationships" xmlns:p="http://schemas.openxmlformats.org/presentationml/2006/main">
+<p:sld xmlns:a="http://schemas.openxmlformats.org/drawingml/2006/main" xmlns:p="http://schemas.openxmlformats.org/presentationml/2006/main" xmlns:r="http://schemas.openxmlformats.org/officeDocument/2006/relationships">
   <p:cSld>
     <p:bg>
       <p:bgPr>
@@ -6294,14 +6260,7 @@
         <p:cNvGrpSpPr/>
         <p:nvPr/>
       </p:nvGrpSpPr>
-      <p:grpSpPr>
-        <a:xfrm>
-          <a:off x="0" y="0"/>
-          <a:ext cx="0" cy="0"/>
-          <a:chOff x="0" y="0"/>
-          <a:chExt cx="0" cy="0"/>
-        </a:xfrm>
-      </p:grpSpPr>
+      <p:grpSpPr/>
       <p:sp>
         <p:nvSpPr>
           <p:cNvPr id="2" name="Rectangle 1"/>
@@ -6343,7 +6302,6 @@
           <a:lstStyle/>
           <a:p>
             <a:pPr algn="ctr"/>
-            <a:endParaRPr/>
           </a:p>
         </p:txBody>
       </p:sp>
@@ -6364,7 +6322,7 @@
           <a:noFill/>
         </p:spPr>
         <p:txBody>
-          <a:bodyPr wrap="square" lIns="0" tIns="0" rIns="0" bIns="0" anchor="t">
+          <a:bodyPr wrap="square" anchor="t" lIns="0" rIns="0" tIns="0" bIns="0">
             <a:spAutoFit/>
           </a:bodyPr>
           <a:lstStyle/>
@@ -6399,7 +6357,7 @@
           <a:noFill/>
         </p:spPr>
         <p:txBody>
-          <a:bodyPr wrap="square" lIns="0" tIns="0" rIns="0" bIns="0" anchor="t">
+          <a:bodyPr wrap="square" anchor="t" lIns="0" rIns="0" tIns="0" bIns="0">
             <a:spAutoFit/>
           </a:bodyPr>
           <a:lstStyle/>
@@ -6434,7 +6392,7 @@
           <a:noFill/>
         </p:spPr>
         <p:txBody>
-          <a:bodyPr wrap="square" lIns="0" tIns="0" rIns="0" bIns="0" anchor="t">
+          <a:bodyPr wrap="square" anchor="t" lIns="0" rIns="0" tIns="0" bIns="0">
             <a:spAutoFit/>
           </a:bodyPr>
           <a:lstStyle/>
@@ -6461,7 +6419,7 @@
 </file>
 
 <file path=ppt/slides/slide4.xml><?xml version="1.0" encoding="utf-8"?>
-<p:sld xmlns:a="http://schemas.openxmlformats.org/drawingml/2006/main" xmlns:r="http://schemas.openxmlformats.org/officeDocument/2006/relationships" xmlns:p="http://schemas.openxmlformats.org/presentationml/2006/main">
+<p:sld xmlns:a="http://schemas.openxmlformats.org/drawingml/2006/main" xmlns:p="http://schemas.openxmlformats.org/presentationml/2006/main" xmlns:r="http://schemas.openxmlformats.org/officeDocument/2006/relationships">
   <p:cSld>
     <p:bg>
       <p:bgPr>
@@ -6477,14 +6435,7 @@
         <p:cNvGrpSpPr/>
         <p:nvPr/>
       </p:nvGrpSpPr>
-      <p:grpSpPr>
-        <a:xfrm>
-          <a:off x="0" y="0"/>
-          <a:ext cx="0" cy="0"/>
-          <a:chOff x="0" y="0"/>
-          <a:chExt cx="0" cy="0"/>
-        </a:xfrm>
-      </p:grpSpPr>
+      <p:grpSpPr/>
       <p:sp>
         <p:nvSpPr>
           <p:cNvPr id="2" name="Rectangle 1"/>
@@ -6526,7 +6477,6 @@
           <a:lstStyle/>
           <a:p>
             <a:pPr algn="ctr"/>
-            <a:endParaRPr/>
           </a:p>
         </p:txBody>
       </p:sp>
@@ -6547,7 +6497,7 @@
           <a:noFill/>
         </p:spPr>
         <p:txBody>
-          <a:bodyPr wrap="square" lIns="0" tIns="0" rIns="0" bIns="0" anchor="t">
+          <a:bodyPr wrap="square" anchor="t" lIns="0" rIns="0" tIns="0" bIns="0">
             <a:spAutoFit/>
           </a:bodyPr>
           <a:lstStyle/>
@@ -6582,7 +6532,7 @@
           <a:noFill/>
         </p:spPr>
         <p:txBody>
-          <a:bodyPr wrap="square" lIns="0" tIns="0" rIns="0" bIns="0" anchor="t">
+          <a:bodyPr wrap="square" anchor="t" lIns="0" rIns="0" tIns="0" bIns="0">
             <a:spAutoFit/>
           </a:bodyPr>
           <a:lstStyle/>
@@ -6617,7 +6567,7 @@
           <a:noFill/>
         </p:spPr>
         <p:txBody>
-          <a:bodyPr wrap="square" lIns="0" tIns="0" rIns="0" bIns="0" anchor="t">
+          <a:bodyPr wrap="square" anchor="t" lIns="0" rIns="0" tIns="0" bIns="0">
             <a:spAutoFit/>
           </a:bodyPr>
           <a:lstStyle/>
@@ -6652,7 +6602,7 @@
           <a:noFill/>
         </p:spPr>
         <p:txBody>
-          <a:bodyPr wrap="square" lIns="0" tIns="0" rIns="0" bIns="0" anchor="t">
+          <a:bodyPr wrap="square" anchor="t" lIns="0" rIns="0" tIns="0" bIns="0">
             <a:spAutoFit/>
           </a:bodyPr>
           <a:lstStyle/>
@@ -6709,7 +6659,7 @@
           </a:fontRef>
         </p:style>
         <p:txBody>
-          <a:bodyPr wrap="square" lIns="73152" tIns="27432" rIns="73152" bIns="27432" rtlCol="0" anchor="ctr"/>
+          <a:bodyPr rtlCol="0" anchor="ctr" wrap="square" lIns="73152" rIns="73152" tIns="27432" bIns="27432"/>
           <a:lstStyle/>
           <a:p>
             <a:pPr algn="l"/>
@@ -6764,7 +6714,7 @@
           </a:fontRef>
         </p:style>
         <p:txBody>
-          <a:bodyPr wrap="square" lIns="73152" tIns="27432" rIns="73152" bIns="27432" rtlCol="0" anchor="ctr"/>
+          <a:bodyPr rtlCol="0" anchor="ctr" wrap="square" lIns="73152" rIns="73152" tIns="27432" bIns="27432"/>
           <a:lstStyle/>
           <a:p>
             <a:pPr algn="l"/>
@@ -6831,7 +6781,7 @@
           </a:fontRef>
         </p:style>
         <p:txBody>
-          <a:bodyPr wrap="square" lIns="73152" tIns="27432" rIns="73152" bIns="27432" rtlCol="0" anchor="ctr"/>
+          <a:bodyPr rtlCol="0" anchor="ctr" wrap="square" lIns="73152" rIns="73152" tIns="27432" bIns="27432"/>
           <a:lstStyle/>
           <a:p>
             <a:pPr algn="l"/>
@@ -6886,7 +6836,7 @@
           </a:fontRef>
         </p:style>
         <p:txBody>
-          <a:bodyPr wrap="square" lIns="73152" tIns="27432" rIns="73152" bIns="27432" rtlCol="0" anchor="ctr"/>
+          <a:bodyPr rtlCol="0" anchor="ctr" wrap="square" lIns="73152" rIns="73152" tIns="27432" bIns="27432"/>
           <a:lstStyle/>
           <a:p>
             <a:pPr algn="l"/>
@@ -6953,7 +6903,7 @@
           </a:fontRef>
         </p:style>
         <p:txBody>
-          <a:bodyPr wrap="square" lIns="73152" tIns="27432" rIns="73152" bIns="27432" rtlCol="0" anchor="ctr"/>
+          <a:bodyPr rtlCol="0" anchor="ctr" wrap="square" lIns="73152" rIns="73152" tIns="27432" bIns="27432"/>
           <a:lstStyle/>
           <a:p>
             <a:pPr algn="l"/>
@@ -7008,7 +6958,7 @@
           </a:fontRef>
         </p:style>
         <p:txBody>
-          <a:bodyPr wrap="square" lIns="73152" tIns="27432" rIns="73152" bIns="27432" rtlCol="0" anchor="ctr"/>
+          <a:bodyPr rtlCol="0" anchor="ctr" wrap="square" lIns="73152" rIns="73152" tIns="27432" bIns="27432"/>
           <a:lstStyle/>
           <a:p>
             <a:pPr algn="l"/>
@@ -7053,7 +7003,7 @@
           <a:noFill/>
         </p:spPr>
         <p:txBody>
-          <a:bodyPr wrap="square" lIns="0" tIns="0" rIns="0" bIns="0" anchor="t">
+          <a:bodyPr wrap="square" anchor="t" lIns="0" rIns="0" tIns="0" bIns="0">
             <a:spAutoFit/>
           </a:bodyPr>
           <a:lstStyle/>
@@ -7088,7 +7038,7 @@
           <a:noFill/>
         </p:spPr>
         <p:txBody>
-          <a:bodyPr wrap="square" lIns="0" tIns="0" rIns="0" bIns="0" anchor="t">
+          <a:bodyPr wrap="square" anchor="t" lIns="0" rIns="0" tIns="0" bIns="0">
             <a:spAutoFit/>
           </a:bodyPr>
           <a:lstStyle/>
@@ -7147,7 +7097,6 @@
           <a:lstStyle/>
           <a:p>
             <a:pPr algn="ctr"/>
-            <a:endParaRPr/>
           </a:p>
         </p:txBody>
       </p:sp>
@@ -7168,7 +7117,7 @@
           <a:noFill/>
         </p:spPr>
         <p:txBody>
-          <a:bodyPr wrap="square" lIns="0" tIns="0" rIns="0" bIns="0" anchor="t">
+          <a:bodyPr wrap="square" anchor="t" lIns="0" rIns="0" tIns="0" bIns="0">
             <a:spAutoFit/>
           </a:bodyPr>
           <a:lstStyle/>
@@ -7203,7 +7152,7 @@
           <a:noFill/>
         </p:spPr>
         <p:txBody>
-          <a:bodyPr wrap="square" lIns="0" tIns="0" rIns="0" bIns="0" anchor="t">
+          <a:bodyPr wrap="square" anchor="t" lIns="0" rIns="0" tIns="0" bIns="0">
             <a:spAutoFit/>
           </a:bodyPr>
           <a:lstStyle/>
@@ -7238,7 +7187,7 @@
           <a:noFill/>
         </p:spPr>
         <p:txBody>
-          <a:bodyPr wrap="square" lIns="0" tIns="0" rIns="0" bIns="0" anchor="t">
+          <a:bodyPr wrap="square" anchor="t" lIns="0" rIns="0" tIns="0" bIns="0">
             <a:spAutoFit/>
           </a:bodyPr>
           <a:lstStyle/>
@@ -7293,7 +7242,7 @@
           <a:noFill/>
         </p:spPr>
         <p:txBody>
-          <a:bodyPr wrap="square" lIns="0" tIns="0" rIns="0" bIns="0" anchor="t">
+          <a:bodyPr wrap="square" anchor="t" lIns="0" rIns="0" tIns="0" bIns="0">
             <a:spAutoFit/>
           </a:bodyPr>
           <a:lstStyle/>
@@ -7348,7 +7297,7 @@
           <a:noFill/>
         </p:spPr>
         <p:txBody>
-          <a:bodyPr wrap="square" lIns="0" tIns="0" rIns="0" bIns="0" anchor="t">
+          <a:bodyPr wrap="square" anchor="t" lIns="0" rIns="0" tIns="0" bIns="0">
             <a:spAutoFit/>
           </a:bodyPr>
           <a:lstStyle/>
@@ -7427,7 +7376,6 @@
           <a:lstStyle/>
           <a:p>
             <a:pPr algn="ctr"/>
-            <a:endParaRPr/>
           </a:p>
         </p:txBody>
       </p:sp>
@@ -7448,7 +7396,7 @@
           <a:noFill/>
         </p:spPr>
         <p:txBody>
-          <a:bodyPr wrap="square" lIns="0" tIns="0" rIns="0" bIns="0" anchor="t">
+          <a:bodyPr wrap="square" anchor="t" lIns="0" rIns="0" tIns="0" bIns="0">
             <a:spAutoFit/>
           </a:bodyPr>
           <a:lstStyle/>
@@ -7483,7 +7431,7 @@
           <a:noFill/>
         </p:spPr>
         <p:txBody>
-          <a:bodyPr wrap="square" lIns="0" tIns="0" rIns="0" bIns="0" anchor="t">
+          <a:bodyPr wrap="square" anchor="t" lIns="0" rIns="0" tIns="0" bIns="0">
             <a:spAutoFit/>
           </a:bodyPr>
           <a:lstStyle/>
@@ -7510,7 +7458,7 @@
 </file>
 
 <file path=ppt/slides/slide5.xml><?xml version="1.0" encoding="utf-8"?>
-<p:sld xmlns:a="http://schemas.openxmlformats.org/drawingml/2006/main" xmlns:r="http://schemas.openxmlformats.org/officeDocument/2006/relationships" xmlns:p="http://schemas.openxmlformats.org/presentationml/2006/main">
+<p:sld xmlns:a="http://schemas.openxmlformats.org/drawingml/2006/main" xmlns:p="http://schemas.openxmlformats.org/presentationml/2006/main" xmlns:r="http://schemas.openxmlformats.org/officeDocument/2006/relationships">
   <p:cSld>
     <p:bg>
       <p:bgPr>
@@ -7526,14 +7474,7 @@
         <p:cNvGrpSpPr/>
         <p:nvPr/>
       </p:nvGrpSpPr>
-      <p:grpSpPr>
-        <a:xfrm>
-          <a:off x="0" y="0"/>
-          <a:ext cx="0" cy="0"/>
-          <a:chOff x="0" y="0"/>
-          <a:chExt cx="0" cy="0"/>
-        </a:xfrm>
-      </p:grpSpPr>
+      <p:grpSpPr/>
       <p:sp>
         <p:nvSpPr>
           <p:cNvPr id="2" name="Rectangle 1"/>
@@ -7575,7 +7516,6 @@
           <a:lstStyle/>
           <a:p>
             <a:pPr algn="ctr"/>
-            <a:endParaRPr/>
           </a:p>
         </p:txBody>
       </p:sp>
@@ -7596,7 +7536,7 @@
           <a:noFill/>
         </p:spPr>
         <p:txBody>
-          <a:bodyPr wrap="square" lIns="0" tIns="0" rIns="0" bIns="0" anchor="t">
+          <a:bodyPr wrap="square" anchor="t" lIns="0" rIns="0" tIns="0" bIns="0">
             <a:spAutoFit/>
           </a:bodyPr>
           <a:lstStyle/>
@@ -7631,7 +7571,7 @@
           <a:noFill/>
         </p:spPr>
         <p:txBody>
-          <a:bodyPr wrap="square" lIns="0" tIns="0" rIns="0" bIns="0" anchor="t">
+          <a:bodyPr wrap="square" anchor="t" lIns="0" rIns="0" tIns="0" bIns="0">
             <a:spAutoFit/>
           </a:bodyPr>
           <a:lstStyle/>
@@ -7666,7 +7606,7 @@
           <a:noFill/>
         </p:spPr>
         <p:txBody>
-          <a:bodyPr wrap="square" lIns="0" tIns="0" rIns="0" bIns="0" anchor="t">
+          <a:bodyPr wrap="square" anchor="t" lIns="0" rIns="0" tIns="0" bIns="0">
             <a:spAutoFit/>
           </a:bodyPr>
           <a:lstStyle/>
@@ -7701,7 +7641,7 @@
           <a:noFill/>
         </p:spPr>
         <p:txBody>
-          <a:bodyPr wrap="square" lIns="0" tIns="0" rIns="0" bIns="0" anchor="t">
+          <a:bodyPr wrap="square" anchor="t" lIns="0" rIns="0" tIns="0" bIns="0">
             <a:spAutoFit/>
           </a:bodyPr>
           <a:lstStyle/>
@@ -7736,7 +7676,7 @@
           <a:noFill/>
         </p:spPr>
         <p:txBody>
-          <a:bodyPr wrap="square" lIns="0" tIns="0" rIns="0" bIns="0" anchor="t">
+          <a:bodyPr wrap="square" anchor="t" lIns="0" rIns="0" tIns="0" bIns="0">
             <a:spAutoFit/>
           </a:bodyPr>
           <a:lstStyle/>
@@ -7791,7 +7731,7 @@
           </a:fontRef>
         </p:style>
         <p:txBody>
-          <a:bodyPr wrap="square" lIns="73152" tIns="27432" rIns="73152" bIns="27432" rtlCol="0" anchor="ctr"/>
+          <a:bodyPr rtlCol="0" anchor="ctr" wrap="square" lIns="73152" rIns="73152" tIns="27432" bIns="27432"/>
           <a:lstStyle/>
           <a:p>
             <a:pPr algn="ctr"/>
@@ -7846,7 +7786,7 @@
           </a:fontRef>
         </p:style>
         <p:txBody>
-          <a:bodyPr wrap="square" lIns="73152" tIns="27432" rIns="73152" bIns="27432" rtlCol="0" anchor="ctr"/>
+          <a:bodyPr rtlCol="0" anchor="ctr" wrap="square" lIns="73152" rIns="73152" tIns="27432" bIns="27432"/>
           <a:lstStyle/>
           <a:p>
             <a:pPr algn="l"/>
@@ -7899,7 +7839,7 @@
           </a:fontRef>
         </p:style>
         <p:txBody>
-          <a:bodyPr wrap="square" lIns="73152" tIns="27432" rIns="73152" bIns="27432" rtlCol="0" anchor="ctr"/>
+          <a:bodyPr rtlCol="0" anchor="ctr" wrap="square" lIns="73152" rIns="73152" tIns="27432" bIns="27432"/>
           <a:lstStyle/>
           <a:p>
             <a:pPr algn="ctr"/>
@@ -7954,7 +7894,7 @@
           </a:fontRef>
         </p:style>
         <p:txBody>
-          <a:bodyPr wrap="square" lIns="73152" tIns="27432" rIns="73152" bIns="27432" rtlCol="0" anchor="ctr"/>
+          <a:bodyPr rtlCol="0" anchor="ctr" wrap="square" lIns="73152" rIns="73152" tIns="27432" bIns="27432"/>
           <a:lstStyle/>
           <a:p>
             <a:pPr algn="l"/>
@@ -8007,7 +7947,7 @@
           </a:fontRef>
         </p:style>
         <p:txBody>
-          <a:bodyPr wrap="square" lIns="73152" tIns="27432" rIns="73152" bIns="27432" rtlCol="0" anchor="ctr"/>
+          <a:bodyPr rtlCol="0" anchor="ctr" wrap="square" lIns="73152" rIns="73152" tIns="27432" bIns="27432"/>
           <a:lstStyle/>
           <a:p>
             <a:pPr algn="ctr"/>
@@ -8062,7 +8002,7 @@
           </a:fontRef>
         </p:style>
         <p:txBody>
-          <a:bodyPr wrap="square" lIns="73152" tIns="27432" rIns="73152" bIns="27432" rtlCol="0" anchor="ctr"/>
+          <a:bodyPr rtlCol="0" anchor="ctr" wrap="square" lIns="73152" rIns="73152" tIns="27432" bIns="27432"/>
           <a:lstStyle/>
           <a:p>
             <a:pPr algn="l"/>
@@ -8115,7 +8055,7 @@
           </a:fontRef>
         </p:style>
         <p:txBody>
-          <a:bodyPr wrap="square" lIns="73152" tIns="27432" rIns="73152" bIns="27432" rtlCol="0" anchor="ctr"/>
+          <a:bodyPr rtlCol="0" anchor="ctr" wrap="square" lIns="73152" rIns="73152" tIns="27432" bIns="27432"/>
           <a:lstStyle/>
           <a:p>
             <a:pPr algn="ctr"/>
@@ -8170,7 +8110,7 @@
           </a:fontRef>
         </p:style>
         <p:txBody>
-          <a:bodyPr wrap="square" lIns="73152" tIns="27432" rIns="73152" bIns="27432" rtlCol="0" anchor="ctr"/>
+          <a:bodyPr rtlCol="0" anchor="ctr" wrap="square" lIns="73152" rIns="73152" tIns="27432" bIns="27432"/>
           <a:lstStyle/>
           <a:p>
             <a:pPr algn="l"/>
@@ -8223,7 +8163,7 @@
           </a:fontRef>
         </p:style>
         <p:txBody>
-          <a:bodyPr wrap="square" lIns="73152" tIns="27432" rIns="73152" bIns="27432" rtlCol="0" anchor="ctr"/>
+          <a:bodyPr rtlCol="0" anchor="ctr" wrap="square" lIns="73152" rIns="73152" tIns="27432" bIns="27432"/>
           <a:lstStyle/>
           <a:p>
             <a:pPr algn="ctr"/>
@@ -8278,7 +8218,7 @@
           </a:fontRef>
         </p:style>
         <p:txBody>
-          <a:bodyPr wrap="square" lIns="73152" tIns="27432" rIns="73152" bIns="27432" rtlCol="0" anchor="ctr"/>
+          <a:bodyPr rtlCol="0" anchor="ctr" wrap="square" lIns="73152" rIns="73152" tIns="27432" bIns="27432"/>
           <a:lstStyle/>
           <a:p>
             <a:pPr algn="l"/>
@@ -8311,7 +8251,7 @@
           <a:noFill/>
         </p:spPr>
         <p:txBody>
-          <a:bodyPr wrap="square" lIns="0" tIns="0" rIns="0" bIns="0" anchor="t">
+          <a:bodyPr wrap="square" anchor="t" lIns="0" rIns="0" tIns="0" bIns="0">
             <a:spAutoFit/>
           </a:bodyPr>
           <a:lstStyle/>
@@ -8366,7 +8306,7 @@
           </a:fontRef>
         </p:style>
         <p:txBody>
-          <a:bodyPr wrap="square" lIns="73152" tIns="27432" rIns="73152" bIns="27432" rtlCol="0" anchor="ctr"/>
+          <a:bodyPr rtlCol="0" anchor="ctr" wrap="square" lIns="73152" rIns="73152" tIns="27432" bIns="27432"/>
           <a:lstStyle/>
           <a:p>
             <a:pPr algn="ctr"/>
@@ -8421,7 +8361,7 @@
           </a:fontRef>
         </p:style>
         <p:txBody>
-          <a:bodyPr wrap="square" lIns="73152" tIns="27432" rIns="73152" bIns="27432" rtlCol="0" anchor="ctr"/>
+          <a:bodyPr rtlCol="0" anchor="ctr" wrap="square" lIns="73152" rIns="73152" tIns="27432" bIns="27432"/>
           <a:lstStyle/>
           <a:p>
             <a:pPr algn="l"/>
@@ -8474,7 +8414,7 @@
           </a:fontRef>
         </p:style>
         <p:txBody>
-          <a:bodyPr wrap="square" lIns="73152" tIns="27432" rIns="73152" bIns="27432" rtlCol="0" anchor="ctr"/>
+          <a:bodyPr rtlCol="0" anchor="ctr" wrap="square" lIns="73152" rIns="73152" tIns="27432" bIns="27432"/>
           <a:lstStyle/>
           <a:p>
             <a:pPr algn="ctr"/>
@@ -8529,7 +8469,7 @@
           </a:fontRef>
         </p:style>
         <p:txBody>
-          <a:bodyPr wrap="square" lIns="73152" tIns="27432" rIns="73152" bIns="27432" rtlCol="0" anchor="ctr"/>
+          <a:bodyPr rtlCol="0" anchor="ctr" wrap="square" lIns="73152" rIns="73152" tIns="27432" bIns="27432"/>
           <a:lstStyle/>
           <a:p>
             <a:pPr algn="l"/>
@@ -8582,7 +8522,7 @@
           </a:fontRef>
         </p:style>
         <p:txBody>
-          <a:bodyPr wrap="square" lIns="73152" tIns="27432" rIns="73152" bIns="27432" rtlCol="0" anchor="ctr"/>
+          <a:bodyPr rtlCol="0" anchor="ctr" wrap="square" lIns="73152" rIns="73152" tIns="27432" bIns="27432"/>
           <a:lstStyle/>
           <a:p>
             <a:pPr algn="ctr"/>
@@ -8637,7 +8577,7 @@
           </a:fontRef>
         </p:style>
         <p:txBody>
-          <a:bodyPr wrap="square" lIns="73152" tIns="27432" rIns="73152" bIns="27432" rtlCol="0" anchor="ctr"/>
+          <a:bodyPr rtlCol="0" anchor="ctr" wrap="square" lIns="73152" rIns="73152" tIns="27432" bIns="27432"/>
           <a:lstStyle/>
           <a:p>
             <a:pPr algn="l"/>
@@ -8670,7 +8610,7 @@
           <a:noFill/>
         </p:spPr>
         <p:txBody>
-          <a:bodyPr wrap="square" lIns="0" tIns="0" rIns="0" bIns="0" anchor="t">
+          <a:bodyPr wrap="square" anchor="t" lIns="0" rIns="0" tIns="0" bIns="0">
             <a:spAutoFit/>
           </a:bodyPr>
           <a:lstStyle/>
@@ -8729,7 +8669,6 @@
           <a:lstStyle/>
           <a:p>
             <a:pPr algn="ctr"/>
-            <a:endParaRPr/>
           </a:p>
         </p:txBody>
       </p:sp>
@@ -8750,7 +8689,7 @@
           <a:noFill/>
         </p:spPr>
         <p:txBody>
-          <a:bodyPr wrap="square" lIns="0" tIns="0" rIns="0" bIns="0" anchor="t">
+          <a:bodyPr wrap="square" anchor="t" lIns="0" rIns="0" tIns="0" bIns="0">
             <a:spAutoFit/>
           </a:bodyPr>
           <a:lstStyle/>
@@ -8807,7 +8746,7 @@
           </a:fontRef>
         </p:style>
         <p:txBody>
-          <a:bodyPr wrap="square" lIns="73152" tIns="27432" rIns="73152" bIns="27432" rtlCol="0" anchor="ctr"/>
+          <a:bodyPr rtlCol="0" anchor="ctr" wrap="square" lIns="73152" rIns="73152" tIns="27432" bIns="27432"/>
           <a:lstStyle/>
           <a:p>
             <a:pPr algn="l"/>
@@ -8876,7 +8815,7 @@
           <a:noFill/>
         </p:spPr>
         <p:txBody>
-          <a:bodyPr wrap="square" lIns="0" tIns="0" rIns="0" bIns="0" anchor="t">
+          <a:bodyPr wrap="square" anchor="t" lIns="0" rIns="0" tIns="0" bIns="0">
             <a:spAutoFit/>
           </a:bodyPr>
           <a:lstStyle/>
@@ -8933,7 +8872,7 @@
           </a:fontRef>
         </p:style>
         <p:txBody>
-          <a:bodyPr wrap="square" lIns="73152" tIns="27432" rIns="73152" bIns="27432" rtlCol="0" anchor="ctr"/>
+          <a:bodyPr rtlCol="0" anchor="ctr" wrap="square" lIns="73152" rIns="73152" tIns="27432" bIns="27432"/>
           <a:lstStyle/>
           <a:p>
             <a:pPr algn="l"/>
@@ -9002,7 +8941,7 @@
           <a:noFill/>
         </p:spPr>
         <p:txBody>
-          <a:bodyPr wrap="square" lIns="0" tIns="0" rIns="0" bIns="0" anchor="t">
+          <a:bodyPr wrap="square" anchor="t" lIns="0" rIns="0" tIns="0" bIns="0">
             <a:spAutoFit/>
           </a:bodyPr>
           <a:lstStyle/>
@@ -9037,7 +8976,7 @@
           <a:noFill/>
         </p:spPr>
         <p:txBody>
-          <a:bodyPr wrap="square" lIns="0" tIns="0" rIns="0" bIns="0" anchor="t">
+          <a:bodyPr wrap="square" anchor="t" lIns="0" rIns="0" tIns="0" bIns="0">
             <a:spAutoFit/>
           </a:bodyPr>
           <a:lstStyle/>
@@ -9092,7 +9031,7 @@
           <a:noFill/>
         </p:spPr>
         <p:txBody>
-          <a:bodyPr wrap="square" lIns="0" tIns="0" rIns="0" bIns="0" anchor="t">
+          <a:bodyPr wrap="square" anchor="t" lIns="0" rIns="0" tIns="0" bIns="0">
             <a:spAutoFit/>
           </a:bodyPr>
           <a:lstStyle/>
@@ -9147,7 +9086,7 @@
           <a:noFill/>
         </p:spPr>
         <p:txBody>
-          <a:bodyPr wrap="square" lIns="0" tIns="0" rIns="0" bIns="0" anchor="t">
+          <a:bodyPr wrap="square" anchor="t" lIns="0" rIns="0" tIns="0" bIns="0">
             <a:spAutoFit/>
           </a:bodyPr>
           <a:lstStyle/>
@@ -9194,7 +9133,7 @@
 </file>
 
 <file path=ppt/slides/slide6.xml><?xml version="1.0" encoding="utf-8"?>
-<p:sld xmlns:a="http://schemas.openxmlformats.org/drawingml/2006/main" xmlns:r="http://schemas.openxmlformats.org/officeDocument/2006/relationships" xmlns:p="http://schemas.openxmlformats.org/presentationml/2006/main">
+<p:sld xmlns:a="http://schemas.openxmlformats.org/drawingml/2006/main" xmlns:p="http://schemas.openxmlformats.org/presentationml/2006/main" xmlns:r="http://schemas.openxmlformats.org/officeDocument/2006/relationships">
   <p:cSld>
     <p:bg>
       <p:bgPr>
@@ -9210,14 +9149,7 @@
         <p:cNvGrpSpPr/>
         <p:nvPr/>
       </p:nvGrpSpPr>
-      <p:grpSpPr>
-        <a:xfrm>
-          <a:off x="0" y="0"/>
-          <a:ext cx="0" cy="0"/>
-          <a:chOff x="0" y="0"/>
-          <a:chExt cx="0" cy="0"/>
-        </a:xfrm>
-      </p:grpSpPr>
+      <p:grpSpPr/>
       <p:sp>
         <p:nvSpPr>
           <p:cNvPr id="2" name="Rectangle 1"/>
@@ -9259,7 +9191,6 @@
           <a:lstStyle/>
           <a:p>
             <a:pPr algn="ctr"/>
-            <a:endParaRPr/>
           </a:p>
         </p:txBody>
       </p:sp>
@@ -9280,7 +9211,7 @@
           <a:noFill/>
         </p:spPr>
         <p:txBody>
-          <a:bodyPr wrap="square" lIns="0" tIns="0" rIns="0" bIns="0" anchor="t">
+          <a:bodyPr wrap="square" anchor="t" lIns="0" rIns="0" tIns="0" bIns="0">
             <a:spAutoFit/>
           </a:bodyPr>
           <a:lstStyle/>
@@ -9315,7 +9246,7 @@
           <a:noFill/>
         </p:spPr>
         <p:txBody>
-          <a:bodyPr wrap="square" lIns="0" tIns="0" rIns="0" bIns="0" anchor="t">
+          <a:bodyPr wrap="square" anchor="t" lIns="0" rIns="0" tIns="0" bIns="0">
             <a:spAutoFit/>
           </a:bodyPr>
           <a:lstStyle/>
@@ -9350,7 +9281,7 @@
           <a:noFill/>
         </p:spPr>
         <p:txBody>
-          <a:bodyPr wrap="square" lIns="0" tIns="0" rIns="0" bIns="0" anchor="t">
+          <a:bodyPr wrap="square" anchor="t" lIns="0" rIns="0" tIns="0" bIns="0">
             <a:spAutoFit/>
           </a:bodyPr>
           <a:lstStyle/>
@@ -9363,7 +9294,7 @@
                 </a:solidFill>
                 <a:latin typeface="Segoe UI"/>
               </a:rPr>
-              <a:t>The cheaper model is measured against your current model's own inconsistency — not against perfection.</a:t>
+              <a:t>The cheaper model is measured against your current model's OWN inconsistency — not against perfection, and not against a written rubric.</a:t>
             </a:r>
           </a:p>
         </p:txBody>
@@ -9376,8 +9307,8 @@
         </p:nvSpPr>
         <p:spPr>
           <a:xfrm>
-            <a:off x="640080" y="2331720"/>
-            <a:ext cx="1874519" cy="1051560"/>
+            <a:off x="640080" y="3108960"/>
+            <a:ext cx="1691640" cy="960120"/>
           </a:xfrm>
           <a:prstGeom prst="roundRect">
             <a:avLst>
@@ -9409,7 +9340,7 @@
           </a:fontRef>
         </p:style>
         <p:txBody>
-          <a:bodyPr wrap="square" lIns="73152" tIns="27432" rIns="73152" bIns="27432" rtlCol="0" anchor="ctr"/>
+          <a:bodyPr rtlCol="0" anchor="ctr" wrap="square" lIns="73152" rIns="73152" tIns="27432" bIns="27432"/>
           <a:lstStyle/>
           <a:p>
             <a:pPr algn="ctr"/>
@@ -9445,8 +9376,8 @@
         </p:nvSpPr>
         <p:spPr>
           <a:xfrm>
-            <a:off x="2788920" y="2331720"/>
-            <a:ext cx="1874519" cy="1051560"/>
+            <a:off x="2697480" y="2194560"/>
+            <a:ext cx="1874519" cy="960120"/>
           </a:xfrm>
           <a:prstGeom prst="roundRect">
             <a:avLst>
@@ -9478,7 +9409,7 @@
           </a:fontRef>
         </p:style>
         <p:txBody>
-          <a:bodyPr wrap="square" lIns="73152" tIns="27432" rIns="73152" bIns="27432" rtlCol="0" anchor="ctr"/>
+          <a:bodyPr rtlCol="0" anchor="ctr" wrap="square" lIns="73152" rIns="73152" tIns="27432" bIns="27432"/>
           <a:lstStyle/>
           <a:p>
             <a:pPr algn="ctr"/>
@@ -9489,7 +9420,7 @@
                 </a:solidFill>
                 <a:latin typeface="Segoe UI"/>
               </a:rPr>
-              <a:t>Re-run each on the</a:t>
+              <a:t>Run the CHEAPER</a:t>
             </a:r>
           </a:p>
           <a:p>
@@ -9501,7 +9432,7 @@
                 </a:solidFill>
                 <a:latin typeface="Segoe UI"/>
               </a:rPr>
-              <a:t>CHEAPER model · 3×</a:t>
+              <a:t>model · 5×</a:t>
             </a:r>
           </a:p>
         </p:txBody>
@@ -9514,8 +9445,8 @@
         </p:nvSpPr>
         <p:spPr>
           <a:xfrm>
-            <a:off x="4937760" y="2331720"/>
-            <a:ext cx="1874519" cy="1051560"/>
+            <a:off x="4846320" y="2194560"/>
+            <a:ext cx="2103120" cy="960120"/>
           </a:xfrm>
           <a:prstGeom prst="roundRect">
             <a:avLst>
@@ -9547,7 +9478,7 @@
           </a:fontRef>
         </p:style>
         <p:txBody>
-          <a:bodyPr wrap="square" lIns="73152" tIns="27432" rIns="73152" bIns="27432" rtlCol="0" anchor="ctr"/>
+          <a:bodyPr rtlCol="0" anchor="ctr" wrap="square" lIns="73152" rIns="73152" tIns="27432" bIns="27432"/>
           <a:lstStyle/>
           <a:p>
             <a:pPr algn="ctr"/>
@@ -9558,7 +9489,7 @@
                 </a:solidFill>
                 <a:latin typeface="Segoe UI"/>
               </a:rPr>
-              <a:t>Judge vs the recorded</a:t>
+              <a:t>Judge each vs the</a:t>
             </a:r>
           </a:p>
           <a:p>
@@ -9570,21 +9501,297 @@
                 </a:solidFill>
                 <a:latin typeface="Segoe UI"/>
               </a:rPr>
-              <a:t>production output</a:t>
-            </a:r>
-          </a:p>
-        </p:txBody>
-      </p:sp>
-      <p:sp>
-        <p:nvSpPr>
-          <p:cNvPr id="9" name="Diamond 8"/>
+              <a:t>reference set · 3× vote</a:t>
+            </a:r>
+          </a:p>
+        </p:txBody>
+      </p:sp>
+      <p:sp>
+        <p:nvSpPr>
+          <p:cNvPr id="9" name="Rounded Rectangle 8"/>
           <p:cNvSpPr/>
           <p:nvPr/>
         </p:nvSpPr>
         <p:spPr>
           <a:xfrm>
-            <a:off x="7086600" y="2194560"/>
-            <a:ext cx="1920240" cy="1325880"/>
+            <a:off x="9921240" y="2194560"/>
+            <a:ext cx="1691640" cy="960120"/>
+          </a:xfrm>
+          <a:prstGeom prst="roundRect">
+            <a:avLst>
+              <a:gd name="adj" fmla="val 8000"/>
+            </a:avLst>
+          </a:prstGeom>
+          <a:solidFill>
+            <a:srgbClr val="0B6B62"/>
+          </a:solidFill>
+          <a:ln w="12700">
+            <a:solidFill>
+              <a:srgbClr val="0B6B62"/>
+            </a:solidFill>
+          </a:ln>
+          <a:effectLst/>
+        </p:spPr>
+        <p:style>
+          <a:lnRef idx="1">
+            <a:schemeClr val="accent1"/>
+          </a:lnRef>
+          <a:fillRef idx="3">
+            <a:schemeClr val="accent1"/>
+          </a:fillRef>
+          <a:effectRef idx="2">
+            <a:schemeClr val="accent1"/>
+          </a:effectRef>
+          <a:fontRef idx="minor">
+            <a:schemeClr val="lt1"/>
+          </a:fontRef>
+        </p:style>
+        <p:txBody>
+          <a:bodyPr rtlCol="0" anchor="ctr" wrap="square" lIns="73152" rIns="73152" tIns="27432" bIns="27432"/>
+          <a:lstStyle/>
+          <a:p>
+            <a:pPr algn="ctr"/>
+            <a:r>
+              <a:rPr sz="1100" b="1">
+                <a:solidFill>
+                  <a:srgbClr val="FFFFFF"/>
+                </a:solidFill>
+                <a:latin typeface="Segoe UI"/>
+              </a:rPr>
+              <a:t>SAFE</a:t>
+            </a:r>
+          </a:p>
+          <a:p>
+            <a:pPr algn="ctr"/>
+            <a:r>
+              <a:rPr sz="1100" b="0">
+                <a:solidFill>
+                  <a:srgbClr val="FFFFFF"/>
+                </a:solidFill>
+                <a:latin typeface="Segoe UI"/>
+              </a:rPr>
+              <a:t>dollars booked</a:t>
+            </a:r>
+          </a:p>
+        </p:txBody>
+      </p:sp>
+      <p:sp>
+        <p:nvSpPr>
+          <p:cNvPr id="10" name="Rounded Rectangle 9"/>
+          <p:cNvSpPr/>
+          <p:nvPr/>
+        </p:nvSpPr>
+        <p:spPr>
+          <a:xfrm>
+            <a:off x="2697480" y="4023360"/>
+            <a:ext cx="1874519" cy="960120"/>
+          </a:xfrm>
+          <a:prstGeom prst="roundRect">
+            <a:avLst>
+              <a:gd name="adj" fmla="val 8000"/>
+            </a:avLst>
+          </a:prstGeom>
+          <a:solidFill>
+            <a:srgbClr val="DCE9E6"/>
+          </a:solidFill>
+          <a:ln w="12700">
+            <a:solidFill>
+              <a:srgbClr val="5E8B84"/>
+            </a:solidFill>
+          </a:ln>
+          <a:effectLst/>
+        </p:spPr>
+        <p:style>
+          <a:lnRef idx="1">
+            <a:schemeClr val="accent1"/>
+          </a:lnRef>
+          <a:fillRef idx="3">
+            <a:schemeClr val="accent1"/>
+          </a:fillRef>
+          <a:effectRef idx="2">
+            <a:schemeClr val="accent1"/>
+          </a:effectRef>
+          <a:fontRef idx="minor">
+            <a:schemeClr val="lt1"/>
+          </a:fontRef>
+        </p:style>
+        <p:txBody>
+          <a:bodyPr rtlCol="0" anchor="ctr" wrap="square" lIns="73152" rIns="73152" tIns="27432" bIns="27432"/>
+          <a:lstStyle/>
+          <a:p>
+            <a:pPr algn="ctr"/>
+            <a:r>
+              <a:rPr sz="1100" b="0">
+                <a:solidFill>
+                  <a:srgbClr val="0C2320"/>
+                </a:solidFill>
+                <a:latin typeface="Segoe UI"/>
+              </a:rPr>
+              <a:t>Run the ORIGINAL 5×</a:t>
+            </a:r>
+          </a:p>
+          <a:p>
+            <a:pPr algn="ctr"/>
+            <a:r>
+              <a:rPr sz="1100" b="0">
+                <a:solidFill>
+                  <a:srgbClr val="0C2320"/>
+                </a:solidFill>
+                <a:latin typeface="Segoe UI"/>
+              </a:rPr>
+              <a:t>= the reference set</a:t>
+            </a:r>
+          </a:p>
+        </p:txBody>
+      </p:sp>
+      <p:sp>
+        <p:nvSpPr>
+          <p:cNvPr id="11" name="Rounded Rectangle 10"/>
+          <p:cNvSpPr/>
+          <p:nvPr/>
+        </p:nvSpPr>
+        <p:spPr>
+          <a:xfrm>
+            <a:off x="4846320" y="4023360"/>
+            <a:ext cx="2103120" cy="960120"/>
+          </a:xfrm>
+          <a:prstGeom prst="roundRect">
+            <a:avLst>
+              <a:gd name="adj" fmla="val 8000"/>
+            </a:avLst>
+          </a:prstGeom>
+          <a:solidFill>
+            <a:srgbClr val="E6E1F0"/>
+          </a:solidFill>
+          <a:ln w="12700">
+            <a:solidFill>
+              <a:srgbClr val="6B5E8A"/>
+            </a:solidFill>
+          </a:ln>
+          <a:effectLst/>
+        </p:spPr>
+        <p:style>
+          <a:lnRef idx="1">
+            <a:schemeClr val="accent1"/>
+          </a:lnRef>
+          <a:fillRef idx="3">
+            <a:schemeClr val="accent1"/>
+          </a:fillRef>
+          <a:effectRef idx="2">
+            <a:schemeClr val="accent1"/>
+          </a:effectRef>
+          <a:fontRef idx="minor">
+            <a:schemeClr val="lt1"/>
+          </a:fontRef>
+        </p:style>
+        <p:txBody>
+          <a:bodyPr rtlCol="0" anchor="ctr" wrap="square" lIns="73152" rIns="73152" tIns="27432" bIns="27432"/>
+          <a:lstStyle/>
+          <a:p>
+            <a:pPr algn="ctr"/>
+            <a:r>
+              <a:rPr sz="1100" b="0">
+                <a:solidFill>
+                  <a:srgbClr val="1E1830"/>
+                </a:solidFill>
+                <a:latin typeface="Segoe UI"/>
+              </a:rPr>
+              <a:t>Each vs the other 4</a:t>
+            </a:r>
+          </a:p>
+          <a:p>
+            <a:pPr algn="ctr"/>
+            <a:r>
+              <a:rPr sz="1100" b="0">
+                <a:solidFill>
+                  <a:srgbClr val="1E1830"/>
+                </a:solidFill>
+                <a:latin typeface="Segoe UI"/>
+              </a:rPr>
+              <a:t>· 3× vote</a:t>
+            </a:r>
+          </a:p>
+        </p:txBody>
+      </p:sp>
+      <p:sp>
+        <p:nvSpPr>
+          <p:cNvPr id="12" name="Rounded Rectangle 11"/>
+          <p:cNvSpPr/>
+          <p:nvPr/>
+        </p:nvSpPr>
+        <p:spPr>
+          <a:xfrm>
+            <a:off x="9921240" y="4023360"/>
+            <a:ext cx="1691640" cy="960120"/>
+          </a:xfrm>
+          <a:prstGeom prst="roundRect">
+            <a:avLst>
+              <a:gd name="adj" fmla="val 8000"/>
+            </a:avLst>
+          </a:prstGeom>
+          <a:solidFill>
+            <a:srgbClr val="F0E5E2"/>
+          </a:solidFill>
+          <a:ln w="12700">
+            <a:solidFill>
+              <a:srgbClr val="9E4030"/>
+            </a:solidFill>
+          </a:ln>
+          <a:effectLst/>
+        </p:spPr>
+        <p:style>
+          <a:lnRef idx="1">
+            <a:schemeClr val="accent1"/>
+          </a:lnRef>
+          <a:fillRef idx="3">
+            <a:schemeClr val="accent1"/>
+          </a:fillRef>
+          <a:effectRef idx="2">
+            <a:schemeClr val="accent1"/>
+          </a:effectRef>
+          <a:fontRef idx="minor">
+            <a:schemeClr val="lt1"/>
+          </a:fontRef>
+        </p:style>
+        <p:txBody>
+          <a:bodyPr rtlCol="0" anchor="ctr" wrap="square" lIns="73152" rIns="73152" tIns="27432" bIns="27432"/>
+          <a:lstStyle/>
+          <a:p>
+            <a:pPr algn="ctr"/>
+            <a:r>
+              <a:rPr sz="1100" b="1">
+                <a:solidFill>
+                  <a:srgbClr val="3A1710"/>
+                </a:solidFill>
+                <a:latin typeface="Segoe UI"/>
+              </a:rPr>
+              <a:t>NOT-SAFE</a:t>
+            </a:r>
+          </a:p>
+          <a:p>
+            <a:pPr algn="ctr"/>
+            <a:r>
+              <a:rPr sz="1100" b="0">
+                <a:solidFill>
+                  <a:srgbClr val="3A1710"/>
+                </a:solidFill>
+                <a:latin typeface="Segoe UI"/>
+              </a:rPr>
+              <a:t>zero</a:t>
+            </a:r>
+          </a:p>
+        </p:txBody>
+      </p:sp>
+      <p:sp>
+        <p:nvSpPr>
+          <p:cNvPr id="13" name="Diamond 12"/>
+          <p:cNvSpPr/>
+          <p:nvPr/>
+        </p:nvSpPr>
+        <p:spPr>
+          <a:xfrm>
+            <a:off x="7360920" y="2761488"/>
+            <a:ext cx="2103120" cy="1517904"/>
           </a:xfrm>
           <a:prstGeom prst="diamond">
             <a:avLst/>
@@ -9614,7 +9821,7 @@
           </a:fontRef>
         </p:style>
         <p:txBody>
-          <a:bodyPr wrap="square" lIns="73152" tIns="27432" rIns="73152" bIns="27432" rtlCol="0" anchor="ctr"/>
+          <a:bodyPr rtlCol="0" anchor="ctr" wrap="square" lIns="73152" rIns="73152" tIns="27432" bIns="27432"/>
           <a:lstStyle/>
           <a:p>
             <a:pPr algn="ctr"/>
@@ -9625,7 +9832,7 @@
                 </a:solidFill>
                 <a:latin typeface="Segoe UI"/>
               </a:rPr>
-              <a:t>Held on every</a:t>
+              <a:t>cheaper n/5 ≥</a:t>
             </a:r>
           </a:p>
           <a:p>
@@ -9637,281 +9844,7 @@
                 </a:solidFill>
                 <a:latin typeface="Segoe UI"/>
               </a:rPr>
-              <a:t>single re-run?</a:t>
-            </a:r>
-          </a:p>
-        </p:txBody>
-      </p:sp>
-      <p:sp>
-        <p:nvSpPr>
-          <p:cNvPr id="10" name="Rounded Rectangle 9"/>
-          <p:cNvSpPr/>
-          <p:nvPr/>
-        </p:nvSpPr>
-        <p:spPr>
-          <a:xfrm>
-            <a:off x="9418320" y="2331720"/>
-            <a:ext cx="2194560" cy="1051560"/>
-          </a:xfrm>
-          <a:prstGeom prst="roundRect">
-            <a:avLst>
-              <a:gd name="adj" fmla="val 8000"/>
-            </a:avLst>
-          </a:prstGeom>
-          <a:solidFill>
-            <a:srgbClr val="0B6B62"/>
-          </a:solidFill>
-          <a:ln w="12700">
-            <a:solidFill>
-              <a:srgbClr val="0B6B62"/>
-            </a:solidFill>
-          </a:ln>
-          <a:effectLst/>
-        </p:spPr>
-        <p:style>
-          <a:lnRef idx="1">
-            <a:schemeClr val="accent1"/>
-          </a:lnRef>
-          <a:fillRef idx="3">
-            <a:schemeClr val="accent1"/>
-          </a:fillRef>
-          <a:effectRef idx="2">
-            <a:schemeClr val="accent1"/>
-          </a:effectRef>
-          <a:fontRef idx="minor">
-            <a:schemeClr val="lt1"/>
-          </a:fontRef>
-        </p:style>
-        <p:txBody>
-          <a:bodyPr wrap="square" lIns="73152" tIns="27432" rIns="73152" bIns="27432" rtlCol="0" anchor="ctr"/>
-          <a:lstStyle/>
-          <a:p>
-            <a:pPr algn="ctr"/>
-            <a:r>
-              <a:rPr sz="1100" b="1">
-                <a:solidFill>
-                  <a:srgbClr val="FFFFFF"/>
-                </a:solidFill>
-                <a:latin typeface="Segoe UI"/>
-              </a:rPr>
-              <a:t>SAFE</a:t>
-            </a:r>
-          </a:p>
-          <a:p>
-            <a:pPr algn="ctr"/>
-            <a:r>
-              <a:rPr sz="1100" b="0">
-                <a:solidFill>
-                  <a:srgbClr val="FFFFFF"/>
-                </a:solidFill>
-                <a:latin typeface="Segoe UI"/>
-              </a:rPr>
-              <a:t>dollars booked</a:t>
-            </a:r>
-          </a:p>
-        </p:txBody>
-      </p:sp>
-      <p:sp>
-        <p:nvSpPr>
-          <p:cNvPr id="11" name="Rounded Rectangle 10"/>
-          <p:cNvSpPr/>
-          <p:nvPr/>
-        </p:nvSpPr>
-        <p:spPr>
-          <a:xfrm>
-            <a:off x="4480560" y="4069080"/>
-            <a:ext cx="2103120" cy="1051560"/>
-          </a:xfrm>
-          <a:prstGeom prst="roundRect">
-            <a:avLst>
-              <a:gd name="adj" fmla="val 8000"/>
-            </a:avLst>
-          </a:prstGeom>
-          <a:solidFill>
-            <a:srgbClr val="DCE9E6"/>
-          </a:solidFill>
-          <a:ln w="12700">
-            <a:solidFill>
-              <a:srgbClr val="5E8B84"/>
-            </a:solidFill>
-          </a:ln>
-          <a:effectLst/>
-        </p:spPr>
-        <p:style>
-          <a:lnRef idx="1">
-            <a:schemeClr val="accent1"/>
-          </a:lnRef>
-          <a:fillRef idx="3">
-            <a:schemeClr val="accent1"/>
-          </a:fillRef>
-          <a:effectRef idx="2">
-            <a:schemeClr val="accent1"/>
-          </a:effectRef>
-          <a:fontRef idx="minor">
-            <a:schemeClr val="lt1"/>
-          </a:fontRef>
-        </p:style>
-        <p:txBody>
-          <a:bodyPr wrap="square" lIns="73152" tIns="27432" rIns="73152" bIns="27432" rtlCol="0" anchor="ctr"/>
-          <a:lstStyle/>
-          <a:p>
-            <a:pPr algn="ctr"/>
-            <a:r>
-              <a:rPr sz="1100" b="0">
-                <a:solidFill>
-                  <a:srgbClr val="0C2320"/>
-                </a:solidFill>
-                <a:latin typeface="Segoe UI"/>
-              </a:rPr>
-              <a:t>NOISE FLOOR: re-run the</a:t>
-            </a:r>
-          </a:p>
-          <a:p>
-            <a:pPr algn="ctr"/>
-            <a:r>
-              <a:rPr sz="1100" b="0">
-                <a:solidFill>
-                  <a:srgbClr val="0C2320"/>
-                </a:solidFill>
-                <a:latin typeface="Segoe UI"/>
-              </a:rPr>
-              <a:t>ORIGINAL model on itself</a:t>
-            </a:r>
-          </a:p>
-        </p:txBody>
-      </p:sp>
-      <p:sp>
-        <p:nvSpPr>
-          <p:cNvPr id="12" name="Diamond 11"/>
-          <p:cNvSpPr/>
-          <p:nvPr/>
-        </p:nvSpPr>
-        <p:spPr>
-          <a:xfrm>
-            <a:off x="7086600" y="3931920"/>
-            <a:ext cx="1920240" cy="1325880"/>
-          </a:xfrm>
-          <a:prstGeom prst="diamond">
-            <a:avLst/>
-          </a:prstGeom>
-          <a:solidFill>
-            <a:srgbClr val="F3F7F6"/>
-          </a:solidFill>
-          <a:ln w="12700">
-            <a:solidFill>
-              <a:srgbClr val="93A8A5"/>
-            </a:solidFill>
-          </a:ln>
-          <a:effectLst/>
-        </p:spPr>
-        <p:style>
-          <a:lnRef idx="1">
-            <a:schemeClr val="accent1"/>
-          </a:lnRef>
-          <a:fillRef idx="3">
-            <a:schemeClr val="accent1"/>
-          </a:fillRef>
-          <a:effectRef idx="2">
-            <a:schemeClr val="accent1"/>
-          </a:effectRef>
-          <a:fontRef idx="minor">
-            <a:schemeClr val="lt1"/>
-          </a:fontRef>
-        </p:style>
-        <p:txBody>
-          <a:bodyPr wrap="square" lIns="73152" tIns="27432" rIns="73152" bIns="27432" rtlCol="0" anchor="ctr"/>
-          <a:lstStyle/>
-          <a:p>
-            <a:pPr algn="ctr"/>
-            <a:r>
-              <a:rPr sz="1000" b="0">
-                <a:solidFill>
-                  <a:srgbClr val="101B1A"/>
-                </a:solidFill>
-                <a:latin typeface="Segoe UI"/>
-              </a:rPr>
-              <a:t>As steady as</a:t>
-            </a:r>
-          </a:p>
-          <a:p>
-            <a:pPr algn="ctr"/>
-            <a:r>
-              <a:rPr sz="1000" b="0">
-                <a:solidFill>
-                  <a:srgbClr val="101B1A"/>
-                </a:solidFill>
-                <a:latin typeface="Segoe UI"/>
-              </a:rPr>
-              <a:t>the original?</a:t>
-            </a:r>
-          </a:p>
-        </p:txBody>
-      </p:sp>
-      <p:sp>
-        <p:nvSpPr>
-          <p:cNvPr id="13" name="Rounded Rectangle 12"/>
-          <p:cNvSpPr/>
-          <p:nvPr/>
-        </p:nvSpPr>
-        <p:spPr>
-          <a:xfrm>
-            <a:off x="9418320" y="4069080"/>
-            <a:ext cx="2194560" cy="1051560"/>
-          </a:xfrm>
-          <a:prstGeom prst="roundRect">
-            <a:avLst>
-              <a:gd name="adj" fmla="val 8000"/>
-            </a:avLst>
-          </a:prstGeom>
-          <a:solidFill>
-            <a:srgbClr val="F0E5E2"/>
-          </a:solidFill>
-          <a:ln w="12700">
-            <a:solidFill>
-              <a:srgbClr val="9E4030"/>
-            </a:solidFill>
-          </a:ln>
-          <a:effectLst/>
-        </p:spPr>
-        <p:style>
-          <a:lnRef idx="1">
-            <a:schemeClr val="accent1"/>
-          </a:lnRef>
-          <a:fillRef idx="3">
-            <a:schemeClr val="accent1"/>
-          </a:fillRef>
-          <a:effectRef idx="2">
-            <a:schemeClr val="accent1"/>
-          </a:effectRef>
-          <a:fontRef idx="minor">
-            <a:schemeClr val="lt1"/>
-          </a:fontRef>
-        </p:style>
-        <p:txBody>
-          <a:bodyPr wrap="square" lIns="73152" tIns="27432" rIns="73152" bIns="27432" rtlCol="0" anchor="ctr"/>
-          <a:lstStyle/>
-          <a:p>
-            <a:pPr algn="ctr"/>
-            <a:r>
-              <a:rPr sz="1100" b="1">
-                <a:solidFill>
-                  <a:srgbClr val="3A1710"/>
-                </a:solidFill>
-                <a:latin typeface="Segoe UI"/>
-              </a:rPr>
-              <a:t>NOT-SAFE</a:t>
-            </a:r>
-          </a:p>
-          <a:p>
-            <a:pPr algn="ctr"/>
-            <a:r>
-              <a:rPr sz="1100" b="0">
-                <a:solidFill>
-                  <a:srgbClr val="3A1710"/>
-                </a:solidFill>
-                <a:latin typeface="Segoe UI"/>
-              </a:rPr>
-              <a:t>zero</a:t>
+              <a:t>original n/5 − 1?</a:t>
             </a:r>
           </a:p>
         </p:txBody>
@@ -9923,9 +9856,9 @@
           <p:nvPr/>
         </p:nvCxnSpPr>
         <p:spPr>
-          <a:xfrm>
-            <a:off x="2514600" y="2857500"/>
-            <a:ext cx="274320" cy="0"/>
+          <a:xfrm flipV="1">
+            <a:off x="2331720" y="2674620"/>
+            <a:ext cx="365760" cy="662940"/>
           </a:xfrm>
           <a:prstGeom prst="line">
             <a:avLst/>
@@ -9960,8 +9893,8 @@
         </p:nvCxnSpPr>
         <p:spPr>
           <a:xfrm>
-            <a:off x="4663440" y="2857500"/>
-            <a:ext cx="274320" cy="0"/>
+            <a:off x="2331720" y="3840480"/>
+            <a:ext cx="365760" cy="662940"/>
           </a:xfrm>
           <a:prstGeom prst="line">
             <a:avLst/>
@@ -9996,7 +9929,7 @@
         </p:nvCxnSpPr>
         <p:spPr>
           <a:xfrm>
-            <a:off x="6812280" y="2857500"/>
+            <a:off x="4572000" y="2674620"/>
             <a:ext cx="274320" cy="0"/>
           </a:xfrm>
           <a:prstGeom prst="line">
@@ -10032,8 +9965,8 @@
         </p:nvCxnSpPr>
         <p:spPr>
           <a:xfrm>
-            <a:off x="9006840" y="2857500"/>
-            <a:ext cx="411480" cy="0"/>
+            <a:off x="4572000" y="4503420"/>
+            <a:ext cx="274320" cy="0"/>
           </a:xfrm>
           <a:prstGeom prst="line">
             <a:avLst/>
@@ -10043,76 +9976,6 @@
               <a:srgbClr val="5E706E"/>
             </a:solidFill>
             <a:tailEnd type="triangle" w="med" len="med"/>
-          </a:ln>
-        </p:spPr>
-        <p:style>
-          <a:lnRef idx="2">
-            <a:schemeClr val="accent1"/>
-          </a:lnRef>
-          <a:fillRef idx="0">
-            <a:schemeClr val="accent1"/>
-          </a:fillRef>
-          <a:effectRef idx="1">
-            <a:schemeClr val="accent1"/>
-          </a:effectRef>
-          <a:fontRef idx="minor">
-            <a:schemeClr val="tx1"/>
-          </a:fontRef>
-        </p:style>
-      </p:cxnSp>
-      <p:sp>
-        <p:nvSpPr>
-          <p:cNvPr id="18" name="TextBox 17"/>
-          <p:cNvSpPr txBox="1"/>
-          <p:nvPr/>
-        </p:nvSpPr>
-        <p:spPr>
-          <a:xfrm>
-            <a:off x="8801100" y="2583180"/>
-            <a:ext cx="822960" cy="201168"/>
-          </a:xfrm>
-          <a:prstGeom prst="rect">
-            <a:avLst/>
-          </a:prstGeom>
-          <a:noFill/>
-        </p:spPr>
-        <p:txBody>
-          <a:bodyPr wrap="square" lIns="0" tIns="0" rIns="0" bIns="0" anchor="t">
-            <a:spAutoFit/>
-          </a:bodyPr>
-          <a:lstStyle/>
-          <a:p>
-            <a:pPr algn="ctr"/>
-            <a:r>
-              <a:rPr sz="900" b="0">
-                <a:solidFill>
-                  <a:srgbClr val="0B6B62"/>
-                </a:solidFill>
-                <a:latin typeface="Consolas"/>
-              </a:rPr>
-              <a:t>yes</a:t>
-            </a:r>
-          </a:p>
-        </p:txBody>
-      </p:sp>
-      <p:cxnSp>
-        <p:nvCxnSpPr>
-          <p:cNvPr id="19" name="Connector 18"/>
-          <p:cNvCxnSpPr/>
-          <p:nvPr/>
-        </p:nvCxnSpPr>
-        <p:spPr>
-          <a:xfrm>
-            <a:off x="8046720" y="3520439"/>
-            <a:ext cx="0" cy="246889"/>
-          </a:xfrm>
-          <a:prstGeom prst="line">
-            <a:avLst/>
-          </a:prstGeom>
-          <a:ln w="15875">
-            <a:solidFill>
-              <a:srgbClr val="5E706E"/>
-            </a:solidFill>
           </a:ln>
         </p:spPr>
         <p:style>
@@ -10132,14 +9995,14 @@
       </p:cxnSp>
       <p:cxnSp>
         <p:nvCxnSpPr>
-          <p:cNvPr id="20" name="Connector 19"/>
+          <p:cNvPr id="18" name="Connector 17"/>
           <p:cNvCxnSpPr/>
           <p:nvPr/>
         </p:nvCxnSpPr>
         <p:spPr>
-          <a:xfrm flipH="1">
-            <a:off x="5532120" y="3767328"/>
-            <a:ext cx="2514600" cy="0"/>
+          <a:xfrm>
+            <a:off x="6949440" y="2674620"/>
+            <a:ext cx="731520" cy="562356"/>
           </a:xfrm>
           <a:prstGeom prst="line">
             <a:avLst/>
@@ -10148,6 +10011,7 @@
             <a:solidFill>
               <a:srgbClr val="5E706E"/>
             </a:solidFill>
+            <a:tailEnd type="triangle" w="med" len="med"/>
           </a:ln>
         </p:spPr>
         <p:style>
@@ -10167,14 +10031,14 @@
       </p:cxnSp>
       <p:cxnSp>
         <p:nvCxnSpPr>
-          <p:cNvPr id="21" name="Connector 20"/>
+          <p:cNvPr id="19" name="Connector 18"/>
           <p:cNvCxnSpPr/>
           <p:nvPr/>
         </p:nvCxnSpPr>
         <p:spPr>
-          <a:xfrm>
-            <a:off x="5532120" y="3767328"/>
-            <a:ext cx="0" cy="301752"/>
+          <a:xfrm flipV="1">
+            <a:off x="6949440" y="3803904"/>
+            <a:ext cx="731520" cy="699516"/>
           </a:xfrm>
           <a:prstGeom prst="line">
             <a:avLst/>
@@ -10203,13 +10067,13 @@
       </p:cxnSp>
       <p:sp>
         <p:nvSpPr>
-          <p:cNvPr id="22" name="TextBox 21"/>
+          <p:cNvPr id="20" name="TextBox 19"/>
           <p:cNvSpPr txBox="1"/>
           <p:nvPr/>
         </p:nvSpPr>
         <p:spPr>
           <a:xfrm>
-            <a:off x="7168896" y="3602735"/>
+            <a:off x="6967728" y="2345436"/>
             <a:ext cx="822960" cy="201168"/>
           </a:xfrm>
           <a:prstGeom prst="rect">
@@ -10218,7 +10082,7 @@
           <a:noFill/>
         </p:spPr>
         <p:txBody>
-          <a:bodyPr wrap="square" lIns="0" tIns="0" rIns="0" bIns="0" anchor="t">
+          <a:bodyPr wrap="square" anchor="t" lIns="0" rIns="0" tIns="0" bIns="0">
             <a:spAutoFit/>
           </a:bodyPr>
           <a:lstStyle/>
@@ -10227,25 +10091,60 @@
             <a:r>
               <a:rPr sz="900" b="0">
                 <a:solidFill>
-                  <a:srgbClr val="9E4030"/>
+                  <a:srgbClr val="0B6B62"/>
                 </a:solidFill>
                 <a:latin typeface="Consolas"/>
               </a:rPr>
-              <a:t>no</a:t>
+              <a:t>cheaper n/5</a:t>
+            </a:r>
+          </a:p>
+        </p:txBody>
+      </p:sp>
+      <p:sp>
+        <p:nvSpPr>
+          <p:cNvPr id="21" name="TextBox 20"/>
+          <p:cNvSpPr txBox="1"/>
+          <p:nvPr/>
+        </p:nvSpPr>
+        <p:spPr>
+          <a:xfrm>
+            <a:off x="6967728" y="4649724"/>
+            <a:ext cx="822960" cy="201168"/>
+          </a:xfrm>
+          <a:prstGeom prst="rect">
+            <a:avLst/>
+          </a:prstGeom>
+          <a:noFill/>
+        </p:spPr>
+        <p:txBody>
+          <a:bodyPr wrap="square" anchor="t" lIns="0" rIns="0" tIns="0" bIns="0">
+            <a:spAutoFit/>
+          </a:bodyPr>
+          <a:lstStyle/>
+          <a:p>
+            <a:pPr algn="ctr"/>
+            <a:r>
+              <a:rPr sz="900" b="0">
+                <a:solidFill>
+                  <a:srgbClr val="556664"/>
+                </a:solidFill>
+                <a:latin typeface="Consolas"/>
+              </a:rPr>
+              <a:t>original n/5</a:t>
             </a:r>
           </a:p>
         </p:txBody>
       </p:sp>
       <p:cxnSp>
         <p:nvCxnSpPr>
-          <p:cNvPr id="23" name="Connector 22"/>
+          <p:cNvPr id="22" name="Connector 21"/>
           <p:cNvCxnSpPr/>
           <p:nvPr/>
         </p:nvCxnSpPr>
         <p:spPr>
-          <a:xfrm>
-            <a:off x="6583680" y="4594860"/>
-            <a:ext cx="502920" cy="0"/>
+          <a:xfrm flipV="1">
+            <a:off x="9144000" y="2674620"/>
+            <a:ext cx="777240" cy="562356"/>
           </a:xfrm>
           <a:prstGeom prst="line">
             <a:avLst/>
@@ -10274,14 +10173,14 @@
       </p:cxnSp>
       <p:cxnSp>
         <p:nvCxnSpPr>
-          <p:cNvPr id="24" name="Connector 23"/>
+          <p:cNvPr id="23" name="Connector 22"/>
           <p:cNvCxnSpPr/>
           <p:nvPr/>
         </p:nvCxnSpPr>
         <p:spPr>
           <a:xfrm>
-            <a:off x="9006840" y="4594860"/>
-            <a:ext cx="411480" cy="0"/>
+            <a:off x="9144000" y="3803904"/>
+            <a:ext cx="777240" cy="699516"/>
           </a:xfrm>
           <a:prstGeom prst="line">
             <a:avLst/>
@@ -10310,13 +10209,48 @@
       </p:cxnSp>
       <p:sp>
         <p:nvSpPr>
+          <p:cNvPr id="24" name="TextBox 23"/>
+          <p:cNvSpPr txBox="1"/>
+          <p:nvPr/>
+        </p:nvSpPr>
+        <p:spPr>
+          <a:xfrm>
+            <a:off x="9308592" y="2363724"/>
+            <a:ext cx="822960" cy="201168"/>
+          </a:xfrm>
+          <a:prstGeom prst="rect">
+            <a:avLst/>
+          </a:prstGeom>
+          <a:noFill/>
+        </p:spPr>
+        <p:txBody>
+          <a:bodyPr wrap="square" anchor="t" lIns="0" rIns="0" tIns="0" bIns="0">
+            <a:spAutoFit/>
+          </a:bodyPr>
+          <a:lstStyle/>
+          <a:p>
+            <a:pPr algn="ctr"/>
+            <a:r>
+              <a:rPr sz="900" b="0">
+                <a:solidFill>
+                  <a:srgbClr val="0B6B62"/>
+                </a:solidFill>
+                <a:latin typeface="Consolas"/>
+              </a:rPr>
+              <a:t>yes</a:t>
+            </a:r>
+          </a:p>
+        </p:txBody>
+      </p:sp>
+      <p:sp>
+        <p:nvSpPr>
           <p:cNvPr id="25" name="TextBox 24"/>
           <p:cNvSpPr txBox="1"/>
           <p:nvPr/>
         </p:nvSpPr>
         <p:spPr>
           <a:xfrm>
-            <a:off x="8801100" y="4320540"/>
+            <a:off x="9308592" y="4613148"/>
             <a:ext cx="822960" cy="201168"/>
           </a:xfrm>
           <a:prstGeom prst="rect">
@@ -10325,7 +10259,7 @@
           <a:noFill/>
         </p:spPr>
         <p:txBody>
-          <a:bodyPr wrap="square" lIns="0" tIns="0" rIns="0" bIns="0" anchor="t">
+          <a:bodyPr wrap="square" anchor="t" lIns="0" rIns="0" tIns="0" bIns="0">
             <a:spAutoFit/>
           </a:bodyPr>
           <a:lstStyle/>
@@ -10343,80 +10277,9 @@
           </a:p>
         </p:txBody>
       </p:sp>
-      <p:cxnSp>
-        <p:nvCxnSpPr>
-          <p:cNvPr id="26" name="Connector 25"/>
-          <p:cNvCxnSpPr/>
-          <p:nvPr/>
-        </p:nvCxnSpPr>
-        <p:spPr>
-          <a:xfrm flipV="1">
-            <a:off x="8046720" y="3383279"/>
-            <a:ext cx="2194560" cy="548641"/>
-          </a:xfrm>
-          <a:prstGeom prst="line">
-            <a:avLst/>
-          </a:prstGeom>
-          <a:ln w="15875">
-            <a:solidFill>
-              <a:srgbClr val="5E706E"/>
-            </a:solidFill>
-            <a:tailEnd type="triangle" w="med" len="med"/>
-          </a:ln>
-        </p:spPr>
-        <p:style>
-          <a:lnRef idx="2">
-            <a:schemeClr val="accent1"/>
-          </a:lnRef>
-          <a:fillRef idx="0">
-            <a:schemeClr val="accent1"/>
-          </a:fillRef>
-          <a:effectRef idx="1">
-            <a:schemeClr val="accent1"/>
-          </a:effectRef>
-          <a:fontRef idx="minor">
-            <a:schemeClr val="tx1"/>
-          </a:fontRef>
-        </p:style>
-      </p:cxnSp>
-      <p:sp>
-        <p:nvSpPr>
-          <p:cNvPr id="27" name="TextBox 26"/>
-          <p:cNvSpPr txBox="1"/>
-          <p:nvPr/>
-        </p:nvSpPr>
-        <p:spPr>
-          <a:xfrm>
-            <a:off x="9006840" y="3657600"/>
-            <a:ext cx="822960" cy="201168"/>
-          </a:xfrm>
-          <a:prstGeom prst="rect">
-            <a:avLst/>
-          </a:prstGeom>
-          <a:noFill/>
-        </p:spPr>
-        <p:txBody>
-          <a:bodyPr wrap="square" lIns="0" tIns="0" rIns="0" bIns="0" anchor="t">
-            <a:spAutoFit/>
-          </a:bodyPr>
-          <a:lstStyle/>
-          <a:p>
-            <a:pPr algn="ctr"/>
-            <a:r>
-              <a:rPr sz="900" b="0">
-                <a:solidFill>
-                  <a:srgbClr val="0B6B62"/>
-                </a:solidFill>
-                <a:latin typeface="Consolas"/>
-              </a:rPr>
-              <a:t>yes</a:t>
-            </a:r>
-          </a:p>
-        </p:txBody>
-      </p:sp>
-      <p:sp>
-        <p:nvSpPr>
-          <p:cNvPr id="28" name="Rectangle 27"/>
+      <p:sp>
+        <p:nvSpPr>
+          <p:cNvPr id="26" name="Rectangle 25"/>
           <p:cNvSpPr/>
           <p:nvPr/>
         </p:nvSpPr>
@@ -10457,13 +10320,12 @@
           <a:lstStyle/>
           <a:p>
             <a:pPr algn="ctr"/>
-            <a:endParaRPr/>
-          </a:p>
-        </p:txBody>
-      </p:sp>
-      <p:sp>
-        <p:nvSpPr>
-          <p:cNvPr id="29" name="TextBox 28"/>
+          </a:p>
+        </p:txBody>
+      </p:sp>
+      <p:sp>
+        <p:nvSpPr>
+          <p:cNvPr id="27" name="TextBox 26"/>
           <p:cNvSpPr txBox="1"/>
           <p:nvPr/>
         </p:nvSpPr>
@@ -10478,7 +10340,7 @@
           <a:noFill/>
         </p:spPr>
         <p:txBody>
-          <a:bodyPr wrap="square" lIns="0" tIns="0" rIns="0" bIns="0" anchor="t">
+          <a:bodyPr wrap="square" anchor="t" lIns="0" rIns="0" tIns="0" bIns="0">
             <a:spAutoFit/>
           </a:bodyPr>
           <a:lstStyle/>
@@ -10498,7 +10360,7 @@
       </p:sp>
       <p:sp>
         <p:nvSpPr>
-          <p:cNvPr id="30" name="Rectangle 29"/>
+          <p:cNvPr id="28" name="Rectangle 27"/>
           <p:cNvSpPr/>
           <p:nvPr/>
         </p:nvSpPr>
@@ -10539,13 +10401,12 @@
           <a:lstStyle/>
           <a:p>
             <a:pPr algn="ctr"/>
-            <a:endParaRPr/>
-          </a:p>
-        </p:txBody>
-      </p:sp>
-      <p:sp>
-        <p:nvSpPr>
-          <p:cNvPr id="31" name="TextBox 30"/>
+          </a:p>
+        </p:txBody>
+      </p:sp>
+      <p:sp>
+        <p:nvSpPr>
+          <p:cNvPr id="29" name="TextBox 28"/>
           <p:cNvSpPr txBox="1"/>
           <p:nvPr/>
         </p:nvSpPr>
@@ -10560,7 +10421,7 @@
           <a:noFill/>
         </p:spPr>
         <p:txBody>
-          <a:bodyPr wrap="square" lIns="0" tIns="0" rIns="0" bIns="0" anchor="t">
+          <a:bodyPr wrap="square" anchor="t" lIns="0" rIns="0" tIns="0" bIns="0">
             <a:spAutoFit/>
           </a:bodyPr>
           <a:lstStyle/>
@@ -10580,7 +10441,7 @@
       </p:sp>
       <p:sp>
         <p:nvSpPr>
-          <p:cNvPr id="32" name="Rectangle 31"/>
+          <p:cNvPr id="30" name="Rectangle 29"/>
           <p:cNvSpPr/>
           <p:nvPr/>
         </p:nvSpPr>
@@ -10621,13 +10482,12 @@
           <a:lstStyle/>
           <a:p>
             <a:pPr algn="ctr"/>
-            <a:endParaRPr/>
-          </a:p>
-        </p:txBody>
-      </p:sp>
-      <p:sp>
-        <p:nvSpPr>
-          <p:cNvPr id="33" name="TextBox 32"/>
+          </a:p>
+        </p:txBody>
+      </p:sp>
+      <p:sp>
+        <p:nvSpPr>
+          <p:cNvPr id="31" name="TextBox 30"/>
           <p:cNvSpPr txBox="1"/>
           <p:nvPr/>
         </p:nvSpPr>
@@ -10642,7 +10502,7 @@
           <a:noFill/>
         </p:spPr>
         <p:txBody>
-          <a:bodyPr wrap="square" lIns="0" tIns="0" rIns="0" bIns="0" anchor="t">
+          <a:bodyPr wrap="square" anchor="t" lIns="0" rIns="0" tIns="0" bIns="0">
             <a:spAutoFit/>
           </a:bodyPr>
           <a:lstStyle/>
@@ -10655,14 +10515,14 @@
                 </a:solidFill>
                 <a:latin typeface="Segoe UI"/>
               </a:rPr>
-              <a:t>AI judgement</a:t>
-            </a:r>
-          </a:p>
-        </p:txBody>
-      </p:sp>
-      <p:sp>
-        <p:nvSpPr>
-          <p:cNvPr id="34" name="Rectangle 33"/>
+              <a:t>AI judgement · voted</a:t>
+            </a:r>
+          </a:p>
+        </p:txBody>
+      </p:sp>
+      <p:sp>
+        <p:nvSpPr>
+          <p:cNvPr id="32" name="Rectangle 31"/>
           <p:cNvSpPr/>
           <p:nvPr/>
         </p:nvSpPr>
@@ -10703,13 +10563,12 @@
           <a:lstStyle/>
           <a:p>
             <a:pPr algn="ctr"/>
-            <a:endParaRPr/>
-          </a:p>
-        </p:txBody>
-      </p:sp>
-      <p:sp>
-        <p:nvSpPr>
-          <p:cNvPr id="35" name="TextBox 34"/>
+          </a:p>
+        </p:txBody>
+      </p:sp>
+      <p:sp>
+        <p:nvSpPr>
+          <p:cNvPr id="33" name="TextBox 32"/>
           <p:cNvSpPr txBox="1"/>
           <p:nvPr/>
         </p:nvSpPr>
@@ -10724,7 +10583,7 @@
           <a:noFill/>
         </p:spPr>
         <p:txBody>
-          <a:bodyPr wrap="square" lIns="0" tIns="0" rIns="0" bIns="0" anchor="t">
+          <a:bodyPr wrap="square" anchor="t" lIns="0" rIns="0" tIns="0" bIns="0">
             <a:spAutoFit/>
           </a:bodyPr>
           <a:lstStyle/>
@@ -10744,7 +10603,7 @@
       </p:sp>
       <p:sp>
         <p:nvSpPr>
-          <p:cNvPr id="36" name="Rectangle 35"/>
+          <p:cNvPr id="34" name="Rectangle 33"/>
           <p:cNvSpPr/>
           <p:nvPr/>
         </p:nvSpPr>
@@ -10785,13 +10644,12 @@
           <a:lstStyle/>
           <a:p>
             <a:pPr algn="ctr"/>
-            <a:endParaRPr/>
-          </a:p>
-        </p:txBody>
-      </p:sp>
-      <p:sp>
-        <p:nvSpPr>
-          <p:cNvPr id="37" name="TextBox 36"/>
+          </a:p>
+        </p:txBody>
+      </p:sp>
+      <p:sp>
+        <p:nvSpPr>
+          <p:cNvPr id="35" name="TextBox 34"/>
           <p:cNvSpPr txBox="1"/>
           <p:nvPr/>
         </p:nvSpPr>
@@ -10806,7 +10664,7 @@
           <a:noFill/>
         </p:spPr>
         <p:txBody>
-          <a:bodyPr wrap="square" lIns="0" tIns="0" rIns="0" bIns="0" anchor="t">
+          <a:bodyPr wrap="square" anchor="t" lIns="0" rIns="0" tIns="0" bIns="0">
             <a:spAutoFit/>
           </a:bodyPr>
           <a:lstStyle/>
@@ -10826,7 +10684,7 @@
       </p:sp>
       <p:sp>
         <p:nvSpPr>
-          <p:cNvPr id="38" name="TextBox 37"/>
+          <p:cNvPr id="36" name="TextBox 35"/>
           <p:cNvSpPr txBox="1"/>
           <p:nvPr/>
         </p:nvSpPr>
@@ -10841,7 +10699,7 @@
           <a:noFill/>
         </p:spPr>
         <p:txBody>
-          <a:bodyPr wrap="square" lIns="0" tIns="0" rIns="0" bIns="0" anchor="t">
+          <a:bodyPr wrap="square" anchor="t" lIns="0" rIns="0" tIns="0" bIns="0">
             <a:spAutoFit/>
           </a:bodyPr>
           <a:lstStyle/>
@@ -10854,7 +10712,7 @@
                 </a:solidFill>
                 <a:latin typeface="Segoe UI"/>
               </a:rPr>
-              <a:t>Large models are not deterministic. Scoring the cheaper model 2-of-3 means nothing until you know your current model also scores 2-of-3 on that input.</a:t>
+              <a:t>The original's own 5 outputs ARE the acceptable range — the cheaper only has to fit it as often as the original fits itself. Every judgement is a majority vote, so one stray judge call can't flip the verdict.</a:t>
             </a:r>
           </a:p>
         </p:txBody>
@@ -10868,7 +10726,7 @@
 </file>
 
 <file path=ppt/slides/slide7.xml><?xml version="1.0" encoding="utf-8"?>
-<p:sld xmlns:a="http://schemas.openxmlformats.org/drawingml/2006/main" xmlns:r="http://schemas.openxmlformats.org/officeDocument/2006/relationships" xmlns:p="http://schemas.openxmlformats.org/presentationml/2006/main">
+<p:sld xmlns:a="http://schemas.openxmlformats.org/drawingml/2006/main" xmlns:p="http://schemas.openxmlformats.org/presentationml/2006/main" xmlns:r="http://schemas.openxmlformats.org/officeDocument/2006/relationships">
   <p:cSld>
     <p:bg>
       <p:bgPr>
@@ -10884,14 +10742,7 @@
         <p:cNvGrpSpPr/>
         <p:nvPr/>
       </p:nvGrpSpPr>
-      <p:grpSpPr>
-        <a:xfrm>
-          <a:off x="0" y="0"/>
-          <a:ext cx="0" cy="0"/>
-          <a:chOff x="0" y="0"/>
-          <a:chExt cx="0" cy="0"/>
-        </a:xfrm>
-      </p:grpSpPr>
+      <p:grpSpPr/>
       <p:sp>
         <p:nvSpPr>
           <p:cNvPr id="2" name="Rectangle 1"/>
@@ -10933,7 +10784,6 @@
           <a:lstStyle/>
           <a:p>
             <a:pPr algn="ctr"/>
-            <a:endParaRPr/>
           </a:p>
         </p:txBody>
       </p:sp>
@@ -10954,7 +10804,7 @@
           <a:noFill/>
         </p:spPr>
         <p:txBody>
-          <a:bodyPr wrap="square" lIns="0" tIns="0" rIns="0" bIns="0" anchor="t">
+          <a:bodyPr wrap="square" anchor="t" lIns="0" rIns="0" tIns="0" bIns="0">
             <a:spAutoFit/>
           </a:bodyPr>
           <a:lstStyle/>
@@ -10989,7 +10839,7 @@
           <a:noFill/>
         </p:spPr>
         <p:txBody>
-          <a:bodyPr wrap="square" lIns="0" tIns="0" rIns="0" bIns="0" anchor="t">
+          <a:bodyPr wrap="square" anchor="t" lIns="0" rIns="0" tIns="0" bIns="0">
             <a:spAutoFit/>
           </a:bodyPr>
           <a:lstStyle/>
@@ -11024,7 +10874,7 @@
           <a:noFill/>
         </p:spPr>
         <p:txBody>
-          <a:bodyPr wrap="square" lIns="0" tIns="0" rIns="0" bIns="0" anchor="t">
+          <a:bodyPr wrap="square" anchor="t" lIns="0" rIns="0" tIns="0" bIns="0">
             <a:spAutoFit/>
           </a:bodyPr>
           <a:lstStyle/>
@@ -11083,7 +10933,7 @@
           </a:fontRef>
         </p:style>
         <p:txBody>
-          <a:bodyPr wrap="square" lIns="73152" tIns="27432" rIns="73152" bIns="27432" rtlCol="0" anchor="ctr"/>
+          <a:bodyPr rtlCol="0" anchor="ctr" wrap="square" lIns="73152" rIns="73152" tIns="27432" bIns="27432"/>
           <a:lstStyle/>
           <a:p>
             <a:pPr algn="ctr"/>
@@ -11152,7 +11002,7 @@
           </a:fontRef>
         </p:style>
         <p:txBody>
-          <a:bodyPr wrap="square" lIns="73152" tIns="27432" rIns="73152" bIns="27432" rtlCol="0" anchor="ctr"/>
+          <a:bodyPr rtlCol="0" anchor="ctr" wrap="square" lIns="73152" rIns="73152" tIns="27432" bIns="27432"/>
           <a:lstStyle/>
           <a:p>
             <a:pPr algn="ctr"/>
@@ -11221,7 +11071,7 @@
           </a:fontRef>
         </p:style>
         <p:txBody>
-          <a:bodyPr wrap="square" lIns="73152" tIns="27432" rIns="73152" bIns="27432" rtlCol="0" anchor="ctr"/>
+          <a:bodyPr rtlCol="0" anchor="ctr" wrap="square" lIns="73152" rIns="73152" tIns="27432" bIns="27432"/>
           <a:lstStyle/>
           <a:p>
             <a:pPr algn="ctr"/>
@@ -11288,7 +11138,7 @@
           </a:fontRef>
         </p:style>
         <p:txBody>
-          <a:bodyPr wrap="square" lIns="73152" tIns="27432" rIns="73152" bIns="27432" rtlCol="0" anchor="ctr"/>
+          <a:bodyPr rtlCol="0" anchor="ctr" wrap="square" lIns="73152" rIns="73152" tIns="27432" bIns="27432"/>
           <a:lstStyle/>
           <a:p>
             <a:pPr algn="ctr"/>
@@ -11357,7 +11207,7 @@
           </a:fontRef>
         </p:style>
         <p:txBody>
-          <a:bodyPr wrap="square" lIns="73152" tIns="27432" rIns="73152" bIns="27432" rtlCol="0" anchor="ctr"/>
+          <a:bodyPr rtlCol="0" anchor="ctr" wrap="square" lIns="73152" rIns="73152" tIns="27432" bIns="27432"/>
           <a:lstStyle/>
           <a:p>
             <a:pPr algn="ctr"/>
@@ -11426,7 +11276,7 @@
           </a:fontRef>
         </p:style>
         <p:txBody>
-          <a:bodyPr wrap="square" lIns="73152" tIns="27432" rIns="73152" bIns="27432" rtlCol="0" anchor="ctr"/>
+          <a:bodyPr rtlCol="0" anchor="ctr" wrap="square" lIns="73152" rIns="73152" tIns="27432" bIns="27432"/>
           <a:lstStyle/>
           <a:p>
             <a:pPr algn="ctr"/>
@@ -11505,7 +11355,7 @@
           </a:fontRef>
         </p:style>
         <p:txBody>
-          <a:bodyPr wrap="square" lIns="73152" tIns="27432" rIns="73152" bIns="27432" rtlCol="0" anchor="ctr"/>
+          <a:bodyPr rtlCol="0" anchor="ctr" wrap="square" lIns="73152" rIns="73152" tIns="27432" bIns="27432"/>
           <a:lstStyle/>
           <a:p>
             <a:pPr algn="ctr"/>
@@ -11574,7 +11424,7 @@
           </a:fontRef>
         </p:style>
         <p:txBody>
-          <a:bodyPr wrap="square" lIns="73152" tIns="27432" rIns="73152" bIns="27432" rtlCol="0" anchor="ctr"/>
+          <a:bodyPr rtlCol="0" anchor="ctr" wrap="square" lIns="73152" rIns="73152" tIns="27432" bIns="27432"/>
           <a:lstStyle/>
           <a:p>
             <a:pPr algn="ctr"/>
@@ -11763,7 +11613,7 @@
           <a:noFill/>
         </p:spPr>
         <p:txBody>
-          <a:bodyPr wrap="square" lIns="0" tIns="0" rIns="0" bIns="0" anchor="t">
+          <a:bodyPr wrap="square" anchor="t" lIns="0" rIns="0" tIns="0" bIns="0">
             <a:spAutoFit/>
           </a:bodyPr>
           <a:lstStyle/>
@@ -11904,7 +11754,7 @@
           <a:noFill/>
         </p:spPr>
         <p:txBody>
-          <a:bodyPr wrap="square" lIns="0" tIns="0" rIns="0" bIns="0" anchor="t">
+          <a:bodyPr wrap="square" anchor="t" lIns="0" rIns="0" tIns="0" bIns="0">
             <a:spAutoFit/>
           </a:bodyPr>
           <a:lstStyle/>
@@ -12011,7 +11861,7 @@
           <a:noFill/>
         </p:spPr>
         <p:txBody>
-          <a:bodyPr wrap="square" lIns="0" tIns="0" rIns="0" bIns="0" anchor="t">
+          <a:bodyPr wrap="square" anchor="t" lIns="0" rIns="0" tIns="0" bIns="0">
             <a:spAutoFit/>
           </a:bodyPr>
           <a:lstStyle/>
@@ -12082,7 +11932,7 @@
           <a:noFill/>
         </p:spPr>
         <p:txBody>
-          <a:bodyPr wrap="square" lIns="0" tIns="0" rIns="0" bIns="0" anchor="t">
+          <a:bodyPr wrap="square" anchor="t" lIns="0" rIns="0" tIns="0" bIns="0">
             <a:spAutoFit/>
           </a:bodyPr>
           <a:lstStyle/>
@@ -12141,7 +11991,6 @@
           <a:lstStyle/>
           <a:p>
             <a:pPr algn="ctr"/>
-            <a:endParaRPr/>
           </a:p>
         </p:txBody>
       </p:sp>
@@ -12162,7 +12011,7 @@
           <a:noFill/>
         </p:spPr>
         <p:txBody>
-          <a:bodyPr wrap="square" lIns="0" tIns="0" rIns="0" bIns="0" anchor="t">
+          <a:bodyPr wrap="square" anchor="t" lIns="0" rIns="0" tIns="0" bIns="0">
             <a:spAutoFit/>
           </a:bodyPr>
           <a:lstStyle/>
@@ -12197,7 +12046,7 @@
           <a:noFill/>
         </p:spPr>
         <p:txBody>
-          <a:bodyPr wrap="square" lIns="0" tIns="0" rIns="0" bIns="0" anchor="t">
+          <a:bodyPr wrap="square" anchor="t" lIns="0" rIns="0" tIns="0" bIns="0">
             <a:spAutoFit/>
           </a:bodyPr>
           <a:lstStyle/>
@@ -12252,7 +12101,7 @@
           <a:noFill/>
         </p:spPr>
         <p:txBody>
-          <a:bodyPr wrap="square" lIns="0" tIns="0" rIns="0" bIns="0" anchor="t">
+          <a:bodyPr wrap="square" anchor="t" lIns="0" rIns="0" tIns="0" bIns="0">
             <a:spAutoFit/>
           </a:bodyPr>
           <a:lstStyle/>
@@ -12307,7 +12156,7 @@
           <a:noFill/>
         </p:spPr>
         <p:txBody>
-          <a:bodyPr wrap="square" lIns="0" tIns="0" rIns="0" bIns="0" anchor="t">
+          <a:bodyPr wrap="square" anchor="t" lIns="0" rIns="0" tIns="0" bIns="0">
             <a:spAutoFit/>
           </a:bodyPr>
           <a:lstStyle/>
@@ -12354,7 +12203,7 @@
 </file>
 
 <file path=ppt/slides/slide8.xml><?xml version="1.0" encoding="utf-8"?>
-<p:sld xmlns:a="http://schemas.openxmlformats.org/drawingml/2006/main" xmlns:r="http://schemas.openxmlformats.org/officeDocument/2006/relationships" xmlns:p="http://schemas.openxmlformats.org/presentationml/2006/main">
+<p:sld xmlns:a="http://schemas.openxmlformats.org/drawingml/2006/main" xmlns:p="http://schemas.openxmlformats.org/presentationml/2006/main" xmlns:r="http://schemas.openxmlformats.org/officeDocument/2006/relationships">
   <p:cSld>
     <p:bg>
       <p:bgPr>
@@ -12370,14 +12219,7 @@
         <p:cNvGrpSpPr/>
         <p:nvPr/>
       </p:nvGrpSpPr>
-      <p:grpSpPr>
-        <a:xfrm>
-          <a:off x="0" y="0"/>
-          <a:ext cx="0" cy="0"/>
-          <a:chOff x="0" y="0"/>
-          <a:chExt cx="0" cy="0"/>
-        </a:xfrm>
-      </p:grpSpPr>
+      <p:grpSpPr/>
       <p:sp>
         <p:nvSpPr>
           <p:cNvPr id="2" name="Rectangle 1"/>
@@ -12419,7 +12261,6 @@
           <a:lstStyle/>
           <a:p>
             <a:pPr algn="ctr"/>
-            <a:endParaRPr/>
           </a:p>
         </p:txBody>
       </p:sp>
@@ -12440,7 +12281,7 @@
           <a:noFill/>
         </p:spPr>
         <p:txBody>
-          <a:bodyPr wrap="square" lIns="0" tIns="0" rIns="0" bIns="0" anchor="t">
+          <a:bodyPr wrap="square" anchor="t" lIns="0" rIns="0" tIns="0" bIns="0">
             <a:spAutoFit/>
           </a:bodyPr>
           <a:lstStyle/>
@@ -12475,7 +12316,7 @@
           <a:noFill/>
         </p:spPr>
         <p:txBody>
-          <a:bodyPr wrap="square" lIns="0" tIns="0" rIns="0" bIns="0" anchor="t">
+          <a:bodyPr wrap="square" anchor="t" lIns="0" rIns="0" tIns="0" bIns="0">
             <a:spAutoFit/>
           </a:bodyPr>
           <a:lstStyle/>
@@ -12510,7 +12351,7 @@
           <a:noFill/>
         </p:spPr>
         <p:txBody>
-          <a:bodyPr wrap="square" lIns="0" tIns="0" rIns="0" bIns="0" anchor="t">
+          <a:bodyPr wrap="square" anchor="t" lIns="0" rIns="0" tIns="0" bIns="0">
             <a:spAutoFit/>
           </a:bodyPr>
           <a:lstStyle/>
@@ -12545,7 +12386,7 @@
           <a:noFill/>
         </p:spPr>
         <p:txBody>
-          <a:bodyPr wrap="square" lIns="0" tIns="0" rIns="0" bIns="0" anchor="t">
+          <a:bodyPr wrap="square" anchor="t" lIns="0" rIns="0" tIns="0" bIns="0">
             <a:spAutoFit/>
           </a:bodyPr>
           <a:lstStyle/>
@@ -12580,7 +12421,7 @@
           <a:noFill/>
         </p:spPr>
         <p:txBody>
-          <a:bodyPr wrap="square" lIns="0" tIns="0" rIns="0" bIns="0" anchor="t">
+          <a:bodyPr wrap="square" anchor="t" lIns="0" rIns="0" tIns="0" bIns="0">
             <a:spAutoFit/>
           </a:bodyPr>
           <a:lstStyle/>
@@ -12615,7 +12456,7 @@
           <a:noFill/>
         </p:spPr>
         <p:txBody>
-          <a:bodyPr wrap="square" lIns="0" tIns="0" rIns="0" bIns="0" anchor="t">
+          <a:bodyPr wrap="square" anchor="t" lIns="0" rIns="0" tIns="0" bIns="0">
             <a:spAutoFit/>
           </a:bodyPr>
           <a:lstStyle/>
@@ -12670,7 +12511,7 @@
           </a:fontRef>
         </p:style>
         <p:txBody>
-          <a:bodyPr wrap="square" lIns="73152" tIns="27432" rIns="73152" bIns="27432" rtlCol="0" anchor="ctr"/>
+          <a:bodyPr rtlCol="0" anchor="ctr" wrap="square" lIns="73152" rIns="73152" tIns="27432" bIns="27432"/>
           <a:lstStyle/>
           <a:p>
             <a:pPr algn="ctr"/>
@@ -12737,7 +12578,7 @@
           </a:fontRef>
         </p:style>
         <p:txBody>
-          <a:bodyPr wrap="square" lIns="73152" tIns="27432" rIns="73152" bIns="27432" rtlCol="0" anchor="ctr"/>
+          <a:bodyPr rtlCol="0" anchor="ctr" wrap="square" lIns="73152" rIns="73152" tIns="27432" bIns="27432"/>
           <a:lstStyle/>
           <a:p>
             <a:pPr algn="l"/>
@@ -12792,27 +12633,18 @@
           </a:fontRef>
         </p:style>
         <p:txBody>
-          <a:bodyPr wrap="square" lIns="73152" tIns="27432" rIns="73152" bIns="27432" rtlCol="0" anchor="ctr"/>
+          <a:bodyPr rtlCol="0" anchor="ctr" wrap="square" lIns="73152" rIns="73152" tIns="27432" bIns="27432"/>
           <a:lstStyle/>
           <a:p>
             <a:pPr algn="l"/>
             <a:r>
-              <a:rPr lang="en-IN" sz="950" b="0" dirty="0">
+              <a:rPr sz="950" b="0">
                 <a:solidFill>
                   <a:srgbClr val="3A1710"/>
                 </a:solidFill>
                 <a:latin typeface="Segoe UI"/>
               </a:rPr>
-              <a:t>RAG-assembled</a:t>
-            </a:r>
-            <a:r>
-              <a:rPr sz="950" b="0" dirty="0">
-                <a:solidFill>
-                  <a:srgbClr val="3A1710"/>
-                </a:solidFill>
-                <a:latin typeface="Segoe UI"/>
-              </a:rPr>
-              <a:t>. The static that survives must clear 1,024–4,096 tokens to cache at all.</a:t>
+              <a:t>RAG-assembled. The static that survives must clear 1,024–4,096 tokens to cache at all.</a:t>
             </a:r>
           </a:p>
         </p:txBody>
@@ -12854,7 +12686,7 @@
           </a:fontRef>
         </p:style>
         <p:txBody>
-          <a:bodyPr wrap="square" lIns="73152" tIns="27432" rIns="73152" bIns="27432" rtlCol="0" anchor="ctr"/>
+          <a:bodyPr rtlCol="0" anchor="ctr" wrap="square" lIns="73152" rIns="73152" tIns="27432" bIns="27432"/>
           <a:lstStyle/>
           <a:p>
             <a:pPr algn="ctr"/>
@@ -12921,7 +12753,7 @@
           </a:fontRef>
         </p:style>
         <p:txBody>
-          <a:bodyPr wrap="square" lIns="73152" tIns="27432" rIns="73152" bIns="27432" rtlCol="0" anchor="ctr"/>
+          <a:bodyPr rtlCol="0" anchor="ctr" wrap="square" lIns="73152" rIns="73152" tIns="27432" bIns="27432"/>
           <a:lstStyle/>
           <a:p>
             <a:pPr algn="l"/>
@@ -12976,7 +12808,7 @@
           </a:fontRef>
         </p:style>
         <p:txBody>
-          <a:bodyPr wrap="square" lIns="73152" tIns="27432" rIns="73152" bIns="27432" rtlCol="0" anchor="ctr"/>
+          <a:bodyPr rtlCol="0" anchor="ctr" wrap="square" lIns="73152" rIns="73152" tIns="27432" bIns="27432"/>
           <a:lstStyle/>
           <a:p>
             <a:pPr algn="l"/>
@@ -13029,7 +12861,7 @@
           </a:fontRef>
         </p:style>
         <p:txBody>
-          <a:bodyPr wrap="square" lIns="73152" tIns="27432" rIns="73152" bIns="27432" rtlCol="0" anchor="ctr"/>
+          <a:bodyPr rtlCol="0" anchor="ctr" wrap="square" lIns="73152" rIns="73152" tIns="27432" bIns="27432"/>
           <a:lstStyle/>
           <a:p>
             <a:pPr algn="ctr"/>
@@ -13096,7 +12928,7 @@
           </a:fontRef>
         </p:style>
         <p:txBody>
-          <a:bodyPr wrap="square" lIns="73152" tIns="27432" rIns="73152" bIns="27432" rtlCol="0" anchor="ctr"/>
+          <a:bodyPr rtlCol="0" anchor="ctr" wrap="square" lIns="73152" rIns="73152" tIns="27432" bIns="27432"/>
           <a:lstStyle/>
           <a:p>
             <a:pPr algn="l"/>
@@ -13151,7 +12983,7 @@
           </a:fontRef>
         </p:style>
         <p:txBody>
-          <a:bodyPr wrap="square" lIns="73152" tIns="27432" rIns="73152" bIns="27432" rtlCol="0" anchor="ctr"/>
+          <a:bodyPr rtlCol="0" anchor="ctr" wrap="square" lIns="73152" rIns="73152" tIns="27432" bIns="27432"/>
           <a:lstStyle/>
           <a:p>
             <a:pPr algn="l"/>
@@ -13208,7 +13040,6 @@
           <a:lstStyle/>
           <a:p>
             <a:pPr algn="ctr"/>
-            <a:endParaRPr/>
           </a:p>
         </p:txBody>
       </p:sp>
@@ -13229,7 +13060,7 @@
           <a:noFill/>
         </p:spPr>
         <p:txBody>
-          <a:bodyPr wrap="square" lIns="0" tIns="0" rIns="0" bIns="0" anchor="t">
+          <a:bodyPr wrap="square" anchor="t" lIns="0" rIns="0" tIns="0" bIns="0">
             <a:spAutoFit/>
           </a:bodyPr>
           <a:lstStyle/>
@@ -13288,7 +13119,7 @@
           </a:fontRef>
         </p:style>
         <p:txBody>
-          <a:bodyPr wrap="square" lIns="73152" tIns="27432" rIns="73152" bIns="27432" rtlCol="0" anchor="ctr"/>
+          <a:bodyPr rtlCol="0" anchor="ctr" wrap="square" lIns="73152" rIns="73152" tIns="27432" bIns="27432"/>
           <a:lstStyle/>
           <a:p>
             <a:pPr algn="ctr"/>
@@ -13369,7 +13200,7 @@
           </a:fontRef>
         </p:style>
         <p:txBody>
-          <a:bodyPr wrap="square" lIns="73152" tIns="27432" rIns="73152" bIns="27432" rtlCol="0" anchor="ctr"/>
+          <a:bodyPr rtlCol="0" anchor="ctr" wrap="square" lIns="73152" rIns="73152" tIns="27432" bIns="27432"/>
           <a:lstStyle/>
           <a:p>
             <a:pPr algn="ctr"/>
@@ -13426,7 +13257,7 @@
           <a:noFill/>
         </p:spPr>
         <p:txBody>
-          <a:bodyPr wrap="square" lIns="0" tIns="0" rIns="0" bIns="0" anchor="t">
+          <a:bodyPr wrap="square" anchor="t" lIns="0" rIns="0" tIns="0" bIns="0">
             <a:spAutoFit/>
           </a:bodyPr>
           <a:lstStyle/>
@@ -13485,7 +13316,6 @@
           <a:lstStyle/>
           <a:p>
             <a:pPr algn="ctr"/>
-            <a:endParaRPr/>
           </a:p>
         </p:txBody>
       </p:sp>
@@ -13506,7 +13336,7 @@
           <a:noFill/>
         </p:spPr>
         <p:txBody>
-          <a:bodyPr wrap="square" lIns="0" tIns="0" rIns="0" bIns="0" anchor="t">
+          <a:bodyPr wrap="square" anchor="t" lIns="0" rIns="0" tIns="0" bIns="0">
             <a:spAutoFit/>
           </a:bodyPr>
           <a:lstStyle/>
@@ -13541,7 +13371,7 @@
           <a:noFill/>
         </p:spPr>
         <p:txBody>
-          <a:bodyPr wrap="square" lIns="0" tIns="0" rIns="0" bIns="0" anchor="t">
+          <a:bodyPr wrap="square" anchor="t" lIns="0" rIns="0" tIns="0" bIns="0">
             <a:spAutoFit/>
           </a:bodyPr>
           <a:lstStyle/>
@@ -13596,7 +13426,7 @@
           <a:noFill/>
         </p:spPr>
         <p:txBody>
-          <a:bodyPr wrap="square" lIns="0" tIns="0" rIns="0" bIns="0" anchor="t">
+          <a:bodyPr wrap="square" anchor="t" lIns="0" rIns="0" tIns="0" bIns="0">
             <a:spAutoFit/>
           </a:bodyPr>
           <a:lstStyle/>
@@ -13973,44 +13803,44 @@
         <a:sysClr val="window" lastClr="FFFFFF"/>
       </a:lt1>
       <a:dk2>
-        <a:srgbClr val="44546A"/>
+        <a:srgbClr val="1F497D"/>
       </a:dk2>
       <a:lt2>
-        <a:srgbClr val="E7E6E6"/>
+        <a:srgbClr val="EEECE1"/>
       </a:lt2>
       <a:accent1>
-        <a:srgbClr val="4472C4"/>
+        <a:srgbClr val="4F81BD"/>
       </a:accent1>
       <a:accent2>
-        <a:srgbClr val="ED7D31"/>
+        <a:srgbClr val="C0504D"/>
       </a:accent2>
       <a:accent3>
-        <a:srgbClr val="A5A5A5"/>
+        <a:srgbClr val="9BBB59"/>
       </a:accent3>
       <a:accent4>
-        <a:srgbClr val="FFC000"/>
+        <a:srgbClr val="8064A2"/>
       </a:accent4>
       <a:accent5>
-        <a:srgbClr val="5B9BD5"/>
+        <a:srgbClr val="4BACC6"/>
       </a:accent5>
       <a:accent6>
-        <a:srgbClr val="70AD47"/>
+        <a:srgbClr val="F79646"/>
       </a:accent6>
       <a:hlink>
-        <a:srgbClr val="0563C1"/>
+        <a:srgbClr val="0000FF"/>
       </a:hlink>
       <a:folHlink>
-        <a:srgbClr val="954F72"/>
+        <a:srgbClr val="800080"/>
       </a:folHlink>
     </a:clrScheme>
     <a:fontScheme name="Office">
       <a:majorFont>
-        <a:latin typeface="Calibri Light" panose="020F0302020204030204"/>
+        <a:latin typeface="Calibri"/>
         <a:ea typeface=""/>
         <a:cs typeface=""/>
-        <a:font script="Jpan" typeface="游ゴシック Light"/>
+        <a:font script="Jpan" typeface="ＭＳ Ｐゴシック"/>
         <a:font script="Hang" typeface="맑은 고딕"/>
-        <a:font script="Hans" typeface="等线 Light"/>
+        <a:font script="Hans" typeface="宋体"/>
         <a:font script="Hant" typeface="新細明體"/>
         <a:font script="Arab" typeface="Times New Roman"/>
         <a:font script="Hebr" typeface="Times New Roman"/>
@@ -14038,31 +13868,14 @@
         <a:font script="Viet" typeface="Times New Roman"/>
         <a:font script="Uigh" typeface="Microsoft Uighur"/>
         <a:font script="Geor" typeface="Sylfaen"/>
-        <a:font script="Armn" typeface="Arial"/>
-        <a:font script="Bugi" typeface="Leelawadee UI"/>
-        <a:font script="Bopo" typeface="Microsoft JhengHei"/>
-        <a:font script="Java" typeface="Javanese Text"/>
-        <a:font script="Lisu" typeface="Segoe UI"/>
-        <a:font script="Mymr" typeface="Myanmar Text"/>
-        <a:font script="Nkoo" typeface="Ebrima"/>
-        <a:font script="Olck" typeface="Nirmala UI"/>
-        <a:font script="Osma" typeface="Ebrima"/>
-        <a:font script="Phag" typeface="Phagspa"/>
-        <a:font script="Syrn" typeface="Estrangelo Edessa"/>
-        <a:font script="Syrj" typeface="Estrangelo Edessa"/>
-        <a:font script="Syre" typeface="Estrangelo Edessa"/>
-        <a:font script="Sora" typeface="Nirmala UI"/>
-        <a:font script="Tale" typeface="Microsoft Tai Le"/>
-        <a:font script="Talu" typeface="Microsoft New Tai Lue"/>
-        <a:font script="Tfng" typeface="Ebrima"/>
       </a:majorFont>
       <a:minorFont>
-        <a:latin typeface="Calibri" panose="020F0502020204030204"/>
+        <a:latin typeface="Calibri"/>
         <a:ea typeface=""/>
         <a:cs typeface=""/>
-        <a:font script="Jpan" typeface="游ゴシック"/>
+        <a:font script="Jpan" typeface="ＭＳ Ｐゴシック"/>
         <a:font script="Hang" typeface="맑은 고딕"/>
-        <a:font script="Hans" typeface="等线"/>
+        <a:font script="Hans" typeface="宋体"/>
         <a:font script="Hant" typeface="新細明體"/>
         <a:font script="Arab" typeface="Arial"/>
         <a:font script="Hebr" typeface="Arial"/>
@@ -14090,23 +13903,6 @@
         <a:font script="Viet" typeface="Arial"/>
         <a:font script="Uigh" typeface="Microsoft Uighur"/>
         <a:font script="Geor" typeface="Sylfaen"/>
-        <a:font script="Armn" typeface="Arial"/>
-        <a:font script="Bugi" typeface="Leelawadee UI"/>
-        <a:font script="Bopo" typeface="Microsoft JhengHei"/>
-        <a:font script="Java" typeface="Javanese Text"/>
-        <a:font script="Lisu" typeface="Segoe UI"/>
-        <a:font script="Mymr" typeface="Myanmar Text"/>
-        <a:font script="Nkoo" typeface="Ebrima"/>
-        <a:font script="Olck" typeface="Nirmala UI"/>
-        <a:font script="Osma" typeface="Ebrima"/>
-        <a:font script="Phag" typeface="Phagspa"/>
-        <a:font script="Syrn" typeface="Estrangelo Edessa"/>
-        <a:font script="Syrj" typeface="Estrangelo Edessa"/>
-        <a:font script="Syre" typeface="Estrangelo Edessa"/>
-        <a:font script="Sora" typeface="Nirmala UI"/>
-        <a:font script="Tale" typeface="Microsoft Tai Le"/>
-        <a:font script="Talu" typeface="Microsoft New Tai Lue"/>
-        <a:font script="Tfng" typeface="Ebrima"/>
       </a:minorFont>
     </a:fontScheme>
     <a:fmtScheme name="Office">
@@ -14118,141 +13914,200 @@
           <a:gsLst>
             <a:gs pos="0">
               <a:schemeClr val="phClr">
-                <a:lumMod val="110000"/>
-                <a:satMod val="105000"/>
-                <a:tint val="67000"/>
+                <a:tint val="50000"/>
+                <a:satMod val="300000"/>
               </a:schemeClr>
             </a:gs>
-            <a:gs pos="50000">
+            <a:gs pos="35000">
               <a:schemeClr val="phClr">
-                <a:lumMod val="105000"/>
-                <a:satMod val="103000"/>
-                <a:tint val="73000"/>
+                <a:tint val="37000"/>
+                <a:satMod val="300000"/>
               </a:schemeClr>
             </a:gs>
             <a:gs pos="100000">
               <a:schemeClr val="phClr">
-                <a:lumMod val="105000"/>
-                <a:satMod val="109000"/>
-                <a:tint val="81000"/>
+                <a:tint val="15000"/>
+                <a:satMod val="350000"/>
               </a:schemeClr>
             </a:gs>
           </a:gsLst>
-          <a:lin ang="5400000" scaled="0"/>
+          <a:lin ang="16200000" scaled="1"/>
         </a:gradFill>
         <a:gradFill rotWithShape="1">
           <a:gsLst>
             <a:gs pos="0">
               <a:schemeClr val="phClr">
-                <a:satMod val="103000"/>
-                <a:lumMod val="102000"/>
-                <a:tint val="94000"/>
-              </a:schemeClr>
-            </a:gs>
-            <a:gs pos="50000">
-              <a:schemeClr val="phClr">
-                <a:satMod val="110000"/>
-                <a:lumMod val="100000"/>
+                <a:tint val="100000"/>
                 <a:shade val="100000"/>
+                <a:satMod val="130000"/>
               </a:schemeClr>
             </a:gs>
             <a:gs pos="100000">
               <a:schemeClr val="phClr">
-                <a:lumMod val="99000"/>
-                <a:satMod val="120000"/>
-                <a:shade val="78000"/>
+                <a:tint val="50000"/>
+                <a:shade val="100000"/>
+                <a:satMod val="350000"/>
               </a:schemeClr>
             </a:gs>
           </a:gsLst>
-          <a:lin ang="5400000" scaled="0"/>
+          <a:lin ang="16200000" scaled="0"/>
         </a:gradFill>
       </a:fillStyleLst>
       <a:lnStyleLst>
-        <a:ln w="6350" cap="flat" cmpd="sng" algn="ctr">
+        <a:ln w="9525" cap="flat" cmpd="sng" algn="ctr">
+          <a:solidFill>
+            <a:schemeClr val="phClr">
+              <a:shade val="95000"/>
+              <a:satMod val="105000"/>
+            </a:schemeClr>
+          </a:solidFill>
+          <a:prstDash val="solid"/>
+        </a:ln>
+        <a:ln w="25400" cap="flat" cmpd="sng" algn="ctr">
           <a:solidFill>
             <a:schemeClr val="phClr"/>
           </a:solidFill>
           <a:prstDash val="solid"/>
-          <a:miter lim="800000"/>
         </a:ln>
-        <a:ln w="12700" cap="flat" cmpd="sng" algn="ctr">
+        <a:ln w="38100" cap="flat" cmpd="sng" algn="ctr">
           <a:solidFill>
             <a:schemeClr val="phClr"/>
           </a:solidFill>
           <a:prstDash val="solid"/>
-          <a:miter lim="800000"/>
-        </a:ln>
-        <a:ln w="19050" cap="flat" cmpd="sng" algn="ctr">
-          <a:solidFill>
-            <a:schemeClr val="phClr"/>
-          </a:solidFill>
-          <a:prstDash val="solid"/>
-          <a:miter lim="800000"/>
         </a:ln>
       </a:lnStyleLst>
       <a:effectStyleLst>
         <a:effectStyle>
-          <a:effectLst/>
-        </a:effectStyle>
-        <a:effectStyle>
-          <a:effectLst/>
+          <a:effectLst>
+            <a:outerShdw blurRad="40000" dist="20000" dir="5400000" rotWithShape="0">
+              <a:srgbClr val="000000">
+                <a:alpha val="38000"/>
+              </a:srgbClr>
+            </a:outerShdw>
+          </a:effectLst>
         </a:effectStyle>
         <a:effectStyle>
           <a:effectLst>
-            <a:outerShdw blurRad="57150" dist="19050" dir="5400000" algn="ctr" rotWithShape="0">
+            <a:outerShdw blurRad="40000" dist="23000" dir="5400000" rotWithShape="0">
               <a:srgbClr val="000000">
-                <a:alpha val="63000"/>
+                <a:alpha val="35000"/>
               </a:srgbClr>
             </a:outerShdw>
           </a:effectLst>
+        </a:effectStyle>
+        <a:effectStyle>
+          <a:effectLst>
+            <a:outerShdw blurRad="40000" dist="23000" dir="5400000" rotWithShape="0">
+              <a:srgbClr val="000000">
+                <a:alpha val="35000"/>
+              </a:srgbClr>
+            </a:outerShdw>
+          </a:effectLst>
+          <a:scene3d>
+            <a:camera prst="orthographicFront">
+              <a:rot lat="0" lon="0" rev="0"/>
+            </a:camera>
+            <a:lightRig rig="threePt" dir="t">
+              <a:rot lat="0" lon="0" rev="1200000"/>
+            </a:lightRig>
+          </a:scene3d>
+          <a:sp3d>
+            <a:bevelT w="63500" h="25400"/>
+          </a:sp3d>
         </a:effectStyle>
       </a:effectStyleLst>
       <a:bgFillStyleLst>
         <a:solidFill>
           <a:schemeClr val="phClr"/>
         </a:solidFill>
-        <a:solidFill>
-          <a:schemeClr val="phClr">
-            <a:tint val="95000"/>
-            <a:satMod val="170000"/>
-          </a:schemeClr>
-        </a:solidFill>
         <a:gradFill rotWithShape="1">
           <a:gsLst>
             <a:gs pos="0">
               <a:schemeClr val="phClr">
-                <a:tint val="93000"/>
-                <a:satMod val="150000"/>
-                <a:shade val="98000"/>
-                <a:lumMod val="102000"/>
+                <a:tint val="40000"/>
+                <a:satMod val="350000"/>
               </a:schemeClr>
             </a:gs>
-            <a:gs pos="50000">
+            <a:gs pos="40000">
               <a:schemeClr val="phClr">
-                <a:tint val="98000"/>
-                <a:satMod val="130000"/>
-                <a:shade val="90000"/>
-                <a:lumMod val="103000"/>
+                <a:tint val="45000"/>
+                <a:shade val="99000"/>
+                <a:satMod val="350000"/>
               </a:schemeClr>
             </a:gs>
             <a:gs pos="100000">
               <a:schemeClr val="phClr">
-                <a:shade val="63000"/>
-                <a:satMod val="120000"/>
+                <a:shade val="20000"/>
+                <a:satMod val="255000"/>
               </a:schemeClr>
             </a:gs>
           </a:gsLst>
-          <a:lin ang="5400000" scaled="0"/>
+          <a:path path="circle">
+            <a:fillToRect l="50000" t="-80000" r="50000" b="180000"/>
+          </a:path>
+        </a:gradFill>
+        <a:gradFill rotWithShape="1">
+          <a:gsLst>
+            <a:gs pos="0">
+              <a:schemeClr val="phClr">
+                <a:tint val="80000"/>
+                <a:satMod val="300000"/>
+              </a:schemeClr>
+            </a:gs>
+            <a:gs pos="100000">
+              <a:schemeClr val="phClr">
+                <a:shade val="30000"/>
+                <a:satMod val="200000"/>
+              </a:schemeClr>
+            </a:gs>
+          </a:gsLst>
+          <a:path path="circle">
+            <a:fillToRect l="50000" t="50000" r="50000" b="50000"/>
+          </a:path>
         </a:gradFill>
       </a:bgFillStyleLst>
     </a:fmtScheme>
   </a:themeElements>
-  <a:objectDefaults/>
+  <a:objectDefaults>
+    <a:spDef>
+      <a:spPr/>
+      <a:bodyPr/>
+      <a:lstStyle/>
+      <a:style>
+        <a:lnRef idx="1">
+          <a:schemeClr val="accent1"/>
+        </a:lnRef>
+        <a:fillRef idx="3">
+          <a:schemeClr val="accent1"/>
+        </a:fillRef>
+        <a:effectRef idx="2">
+          <a:schemeClr val="accent1"/>
+        </a:effectRef>
+        <a:fontRef idx="minor">
+          <a:schemeClr val="lt1"/>
+        </a:fontRef>
+      </a:style>
+    </a:spDef>
+    <a:lnDef>
+      <a:spPr/>
+      <a:bodyPr/>
+      <a:lstStyle/>
+      <a:style>
+        <a:lnRef idx="2">
+          <a:schemeClr val="accent1"/>
+        </a:lnRef>
+        <a:fillRef idx="0">
+          <a:schemeClr val="accent1"/>
+        </a:fillRef>
+        <a:effectRef idx="1">
+          <a:schemeClr val="accent1"/>
+        </a:effectRef>
+        <a:fontRef idx="minor">
+          <a:schemeClr val="tx1"/>
+        </a:fontRef>
+      </a:style>
+    </a:lnDef>
+  </a:objectDefaults>
   <a:extraClrSchemeLst/>
-  <a:extLst>
-    <a:ext uri="{05A4C25C-085E-4340-85A3-A5531E510DB2}">
-      <thm15:themeFamily xmlns:thm15="http://schemas.microsoft.com/office/thememl/2012/main" name="Office Theme" id="{62F939B6-93AF-4DB8-9C6B-D6C7DFDC589F}" vid="{4A3C46E8-61CC-4603-A589-7422A47A8E4A}"/>
-    </a:ext>
-  </a:extLst>
 </a:theme>
 </file>
</xml_diff>